<commit_message>
Update PhishingAwareness with changes
</commit_message>
<xml_diff>
--- a/PhishingAwareness.pptx
+++ b/PhishingAwareness.pptx
@@ -4,6 +4,9 @@
   <p:sldMasterIdLst>
     <p:sldMasterId id="2147483648" r:id="rId1"/>
   </p:sldMasterIdLst>
+  <p:notesMasterIdLst>
+    <p:notesMasterId r:id="rId10"/>
+  </p:notesMasterIdLst>
   <p:sldIdLst>
     <p:sldId id="256" r:id="rId2"/>
     <p:sldId id="257" r:id="rId3"/>
@@ -14,10 +17,7 @@
     <p:sldId id="262" r:id="rId8"/>
     <p:sldId id="263" r:id="rId9"/>
   </p:sldIdLst>
-  <p:notesMasterIdLst>
-    <p:notesMasterId r:id="rId10"/>
-  </p:notesMasterIdLst>
-  <p:sldSz cx="9144000" cy="5143500"/>
+  <p:sldSz cx="9144000" cy="5143500" type="screen16x9"/>
   <p:notesSz cx="5143500" cy="9144000"/>
   <p:defaultTextStyle>
     <a:lvl1pPr marL="0" algn="l" defTabSz="914400" rtl="0" eaLnBrk="1" latinLnBrk="0" hangingPunct="1">
@@ -111,7 +111,195 @@
       </a:defRPr>
     </a:lvl9pPr>
   </p:defaultTextStyle>
+  <p:extLst>
+    <p:ext uri="{EFAFB233-063F-42B5-8137-9DF3F51BA10A}">
+      <p15:sldGuideLst xmlns:p15="http://schemas.microsoft.com/office/powerpoint/2012/main"/>
+    </p:ext>
+  </p:extLst>
 </p:presentation>
+</file>
+
+<file path=ppt/changesInfos/changesInfo1.xml><?xml version="1.0" encoding="utf-8"?>
+<pc:chgInfo xmlns:a="http://schemas.openxmlformats.org/drawingml/2006/main" xmlns:r="http://schemas.openxmlformats.org/officeDocument/2006/relationships" xmlns:ac="http://schemas.microsoft.com/office/drawing/2013/main/command" xmlns:pc="http://schemas.microsoft.com/office/powerpoint/2013/main/command">
+  <pc:docChgLst>
+    <pc:chgData name="Kashaf Sb" userId="387b347b81619e04" providerId="LiveId" clId="{D9CA0D37-D25D-4C4E-B901-F137B781A5B2}"/>
+    <pc:docChg chg="undo custSel modSld">
+      <pc:chgData name="Kashaf Sb" userId="387b347b81619e04" providerId="LiveId" clId="{D9CA0D37-D25D-4C4E-B901-F137B781A5B2}" dt="2026-05-01T11:11:08.646" v="104" actId="20577"/>
+      <pc:docMkLst>
+        <pc:docMk/>
+      </pc:docMkLst>
+      <pc:sldChg chg="modSp mod">
+        <pc:chgData name="Kashaf Sb" userId="387b347b81619e04" providerId="LiveId" clId="{D9CA0D37-D25D-4C4E-B901-F137B781A5B2}" dt="2026-05-01T11:11:08.646" v="104" actId="20577"/>
+        <pc:sldMkLst>
+          <pc:docMk/>
+          <pc:sldMk cId="0" sldId="256"/>
+        </pc:sldMkLst>
+        <pc:spChg chg="mod">
+          <ac:chgData name="Kashaf Sb" userId="387b347b81619e04" providerId="LiveId" clId="{D9CA0D37-D25D-4C4E-B901-F137B781A5B2}" dt="2026-05-01T11:07:27.038" v="6" actId="20577"/>
+          <ac:spMkLst>
+            <pc:docMk/>
+            <pc:sldMk cId="0" sldId="256"/>
+            <ac:spMk id="3" creationId="{00000000-0000-0000-0000-000000000000}"/>
+          </ac:spMkLst>
+        </pc:spChg>
+        <pc:spChg chg="mod">
+          <ac:chgData name="Kashaf Sb" userId="387b347b81619e04" providerId="LiveId" clId="{D9CA0D37-D25D-4C4E-B901-F137B781A5B2}" dt="2026-05-01T11:10:54.029" v="59" actId="14100"/>
+          <ac:spMkLst>
+            <pc:docMk/>
+            <pc:sldMk cId="0" sldId="256"/>
+            <ac:spMk id="7" creationId="{00000000-0000-0000-0000-000000000000}"/>
+          </ac:spMkLst>
+        </pc:spChg>
+        <pc:spChg chg="mod">
+          <ac:chgData name="Kashaf Sb" userId="387b347b81619e04" providerId="LiveId" clId="{D9CA0D37-D25D-4C4E-B901-F137B781A5B2}" dt="2026-05-01T11:11:08.646" v="104" actId="20577"/>
+          <ac:spMkLst>
+            <pc:docMk/>
+            <pc:sldMk cId="0" sldId="256"/>
+            <ac:spMk id="16" creationId="{00000000-0000-0000-0000-000000000000}"/>
+          </ac:spMkLst>
+        </pc:spChg>
+      </pc:sldChg>
+      <pc:sldChg chg="modSp mod">
+        <pc:chgData name="Kashaf Sb" userId="387b347b81619e04" providerId="LiveId" clId="{D9CA0D37-D25D-4C4E-B901-F137B781A5B2}" dt="2026-05-01T11:07:46.472" v="17" actId="20577"/>
+        <pc:sldMkLst>
+          <pc:docMk/>
+          <pc:sldMk cId="0" sldId="257"/>
+        </pc:sldMkLst>
+        <pc:spChg chg="mod">
+          <ac:chgData name="Kashaf Sb" userId="387b347b81619e04" providerId="LiveId" clId="{D9CA0D37-D25D-4C4E-B901-F137B781A5B2}" dt="2026-05-01T11:07:46.472" v="17" actId="20577"/>
+          <ac:spMkLst>
+            <pc:docMk/>
+            <pc:sldMk cId="0" sldId="257"/>
+            <ac:spMk id="3" creationId="{00000000-0000-0000-0000-000000000000}"/>
+          </ac:spMkLst>
+        </pc:spChg>
+        <pc:spChg chg="mod">
+          <ac:chgData name="Kashaf Sb" userId="387b347b81619e04" providerId="LiveId" clId="{D9CA0D37-D25D-4C4E-B901-F137B781A5B2}" dt="2026-05-01T11:07:37.449" v="14" actId="20577"/>
+          <ac:spMkLst>
+            <pc:docMk/>
+            <pc:sldMk cId="0" sldId="257"/>
+            <ac:spMk id="7" creationId="{00000000-0000-0000-0000-000000000000}"/>
+          </ac:spMkLst>
+        </pc:spChg>
+      </pc:sldChg>
+      <pc:sldChg chg="modSp mod">
+        <pc:chgData name="Kashaf Sb" userId="387b347b81619e04" providerId="LiveId" clId="{D9CA0D37-D25D-4C4E-B901-F137B781A5B2}" dt="2026-05-01T11:07:52.806" v="20" actId="20577"/>
+        <pc:sldMkLst>
+          <pc:docMk/>
+          <pc:sldMk cId="0" sldId="258"/>
+        </pc:sldMkLst>
+        <pc:spChg chg="mod">
+          <ac:chgData name="Kashaf Sb" userId="387b347b81619e04" providerId="LiveId" clId="{D9CA0D37-D25D-4C4E-B901-F137B781A5B2}" dt="2026-05-01T11:07:52.806" v="20" actId="20577"/>
+          <ac:spMkLst>
+            <pc:docMk/>
+            <pc:sldMk cId="0" sldId="258"/>
+            <ac:spMk id="3" creationId="{00000000-0000-0000-0000-000000000000}"/>
+          </ac:spMkLst>
+        </pc:spChg>
+      </pc:sldChg>
+      <pc:sldChg chg="modSp mod">
+        <pc:chgData name="Kashaf Sb" userId="387b347b81619e04" providerId="LiveId" clId="{D9CA0D37-D25D-4C4E-B901-F137B781A5B2}" dt="2026-05-01T11:08:13.369" v="27" actId="20577"/>
+        <pc:sldMkLst>
+          <pc:docMk/>
+          <pc:sldMk cId="0" sldId="259"/>
+        </pc:sldMkLst>
+        <pc:spChg chg="mod">
+          <ac:chgData name="Kashaf Sb" userId="387b347b81619e04" providerId="LiveId" clId="{D9CA0D37-D25D-4C4E-B901-F137B781A5B2}" dt="2026-05-01T11:08:04.525" v="23" actId="20577"/>
+          <ac:spMkLst>
+            <pc:docMk/>
+            <pc:sldMk cId="0" sldId="259"/>
+            <ac:spMk id="3" creationId="{00000000-0000-0000-0000-000000000000}"/>
+          </ac:spMkLst>
+        </pc:spChg>
+        <pc:spChg chg="mod">
+          <ac:chgData name="Kashaf Sb" userId="387b347b81619e04" providerId="LiveId" clId="{D9CA0D37-D25D-4C4E-B901-F137B781A5B2}" dt="2026-05-01T11:08:13.369" v="27" actId="20577"/>
+          <ac:spMkLst>
+            <pc:docMk/>
+            <pc:sldMk cId="0" sldId="259"/>
+            <ac:spMk id="40" creationId="{00000000-0000-0000-0000-000000000000}"/>
+          </ac:spMkLst>
+        </pc:spChg>
+      </pc:sldChg>
+      <pc:sldChg chg="modSp mod">
+        <pc:chgData name="Kashaf Sb" userId="387b347b81619e04" providerId="LiveId" clId="{D9CA0D37-D25D-4C4E-B901-F137B781A5B2}" dt="2026-05-01T11:08:46.454" v="36" actId="20577"/>
+        <pc:sldMkLst>
+          <pc:docMk/>
+          <pc:sldMk cId="0" sldId="260"/>
+        </pc:sldMkLst>
+        <pc:spChg chg="mod">
+          <ac:chgData name="Kashaf Sb" userId="387b347b81619e04" providerId="LiveId" clId="{D9CA0D37-D25D-4C4E-B901-F137B781A5B2}" dt="2026-05-01T11:08:24.062" v="30" actId="20577"/>
+          <ac:spMkLst>
+            <pc:docMk/>
+            <pc:sldMk cId="0" sldId="260"/>
+            <ac:spMk id="3" creationId="{00000000-0000-0000-0000-000000000000}"/>
+          </ac:spMkLst>
+        </pc:spChg>
+        <pc:spChg chg="mod">
+          <ac:chgData name="Kashaf Sb" userId="387b347b81619e04" providerId="LiveId" clId="{D9CA0D37-D25D-4C4E-B901-F137B781A5B2}" dt="2026-05-01T11:08:31.964" v="33" actId="20577"/>
+          <ac:spMkLst>
+            <pc:docMk/>
+            <pc:sldMk cId="0" sldId="260"/>
+            <ac:spMk id="16" creationId="{00000000-0000-0000-0000-000000000000}"/>
+          </ac:spMkLst>
+        </pc:spChg>
+        <pc:spChg chg="mod">
+          <ac:chgData name="Kashaf Sb" userId="387b347b81619e04" providerId="LiveId" clId="{D9CA0D37-D25D-4C4E-B901-F137B781A5B2}" dt="2026-05-01T11:08:46.454" v="36" actId="20577"/>
+          <ac:spMkLst>
+            <pc:docMk/>
+            <pc:sldMk cId="0" sldId="260"/>
+            <ac:spMk id="26" creationId="{00000000-0000-0000-0000-000000000000}"/>
+          </ac:spMkLst>
+        </pc:spChg>
+      </pc:sldChg>
+      <pc:sldChg chg="modSp mod">
+        <pc:chgData name="Kashaf Sb" userId="387b347b81619e04" providerId="LiveId" clId="{D9CA0D37-D25D-4C4E-B901-F137B781A5B2}" dt="2026-05-01T11:09:12.409" v="50" actId="20577"/>
+        <pc:sldMkLst>
+          <pc:docMk/>
+          <pc:sldMk cId="0" sldId="261"/>
+        </pc:sldMkLst>
+        <pc:spChg chg="mod">
+          <ac:chgData name="Kashaf Sb" userId="387b347b81619e04" providerId="LiveId" clId="{D9CA0D37-D25D-4C4E-B901-F137B781A5B2}" dt="2026-05-01T11:08:56.468" v="39" actId="20577"/>
+          <ac:spMkLst>
+            <pc:docMk/>
+            <pc:sldMk cId="0" sldId="261"/>
+            <ac:spMk id="3" creationId="{00000000-0000-0000-0000-000000000000}"/>
+          </ac:spMkLst>
+        </pc:spChg>
+        <pc:spChg chg="mod">
+          <ac:chgData name="Kashaf Sb" userId="387b347b81619e04" providerId="LiveId" clId="{D9CA0D37-D25D-4C4E-B901-F137B781A5B2}" dt="2026-05-01T11:09:04.592" v="43" actId="20577"/>
+          <ac:spMkLst>
+            <pc:docMk/>
+            <pc:sldMk cId="0" sldId="261"/>
+            <ac:spMk id="12" creationId="{00000000-0000-0000-0000-000000000000}"/>
+          </ac:spMkLst>
+        </pc:spChg>
+        <pc:spChg chg="mod">
+          <ac:chgData name="Kashaf Sb" userId="387b347b81619e04" providerId="LiveId" clId="{D9CA0D37-D25D-4C4E-B901-F137B781A5B2}" dt="2026-05-01T11:09:12.409" v="50" actId="20577"/>
+          <ac:spMkLst>
+            <pc:docMk/>
+            <pc:sldMk cId="0" sldId="261"/>
+            <ac:spMk id="20" creationId="{00000000-0000-0000-0000-000000000000}"/>
+          </ac:spMkLst>
+        </pc:spChg>
+      </pc:sldChg>
+      <pc:sldChg chg="modSp mod">
+        <pc:chgData name="Kashaf Sb" userId="387b347b81619e04" providerId="LiveId" clId="{D9CA0D37-D25D-4C4E-B901-F137B781A5B2}" dt="2026-05-01T11:10:21.028" v="55" actId="255"/>
+        <pc:sldMkLst>
+          <pc:docMk/>
+          <pc:sldMk cId="0" sldId="263"/>
+        </pc:sldMkLst>
+        <pc:spChg chg="mod">
+          <ac:chgData name="Kashaf Sb" userId="387b347b81619e04" providerId="LiveId" clId="{D9CA0D37-D25D-4C4E-B901-F137B781A5B2}" dt="2026-05-01T11:10:21.028" v="55" actId="255"/>
+          <ac:spMkLst>
+            <pc:docMk/>
+            <pc:sldMk cId="0" sldId="263"/>
+            <ac:spMk id="12" creationId="{00000000-0000-0000-0000-000000000000}"/>
+          </ac:spMkLst>
+        </pc:spChg>
+      </pc:sldChg>
+    </pc:docChg>
+  </pc:docChgLst>
+</pc:chgInfo>
 </file>
 
 <file path=ppt/notesMasters/notesMaster1.xml><?xml version="1.0" encoding="utf-8"?>
@@ -136,234 +324,10 @@
           <a:chExt cx="0" cy="0"/>
         </a:xfrm>
       </p:grpSpPr>
-      <p:sp>
-        <p:nvSpPr>
-          <p:cNvPr id="2" name="Header Placeholder 1"/>
-          <p:cNvSpPr>
-            <a:spLocks noGrp="1"/>
-          </p:cNvSpPr>
-          <p:nvPr>
-            <p:ph type="hdr" sz="quarter"/>
-          </p:nvPr>
-        </p:nvSpPr>
-        <p:spPr>
-          <a:xfrm>
-            <a:off x="0" y="0"/>
-            <a:ext cx="2971800" cy="458788"/>
-          </a:xfrm>
-          <a:prstGeom prst="rect">
-            <a:avLst/>
-          </a:prstGeom>
-        </p:spPr>
-        <p:txBody>
-          <a:bodyPr vert="horz" lIns="91440" tIns="45720" rIns="91440" bIns="45720" rtlCol="0"/>
-          <a:lstStyle>
-            <a:lvl1pPr algn="l">
-              <a:defRPr sz="1200"/>
-            </a:lvl1pPr>
-          </a:lstStyle>
-          <a:p>
-            <a:endParaRPr lang="en-US"/>
-          </a:p>
-        </p:txBody>
-      </p:sp>
-      <p:sp>
-        <p:nvSpPr>
-          <p:cNvPr id="3" name="Date Placeholder 2"/>
-          <p:cNvSpPr>
-            <a:spLocks noGrp="1"/>
-          </p:cNvSpPr>
-          <p:nvPr>
-            <p:ph type="dt" idx="1"/>
-          </p:nvPr>
-        </p:nvSpPr>
-        <p:spPr>
-          <a:xfrm>
-            <a:off x="3884613" y="0"/>
-            <a:ext cx="2971800" cy="458788"/>
-          </a:xfrm>
-          <a:prstGeom prst="rect">
-            <a:avLst/>
-          </a:prstGeom>
-        </p:spPr>
-        <p:txBody>
-          <a:bodyPr vert="horz" lIns="91440" tIns="45720" rIns="91440" bIns="45720" rtlCol="0"/>
-          <a:lstStyle>
-            <a:lvl1pPr algn="r">
-              <a:defRPr sz="1200"/>
-            </a:lvl1pPr>
-          </a:lstStyle>
-          <a:p>
-            <a:fld id="{5282F153-3F37-0F45-9E97-73ACFA13230C}" type="datetimeFigureOut">
-              <a:rPr lang="en-US"/>
-              <a:t>7/23/19</a:t>
-            </a:fld>
-            <a:endParaRPr lang="en-US"/>
-          </a:p>
-        </p:txBody>
-      </p:sp>
-      <p:sp>
-        <p:nvSpPr>
-          <p:cNvPr id="4" name="Slide Image Placeholder 3"/>
-          <p:cNvSpPr>
-            <a:spLocks noGrp="1" noRot="1" noChangeAspect="1"/>
-          </p:cNvSpPr>
-          <p:nvPr>
-            <p:ph type="sldImg" idx="2"/>
-          </p:nvPr>
-        </p:nvSpPr>
-        <p:spPr>
-          <a:xfrm>
-            <a:off x="685800" y="1143000"/>
-            <a:ext cx="5486400" cy="3086100"/>
-          </a:xfrm>
-          <a:prstGeom prst="rect">
-            <a:avLst/>
-          </a:prstGeom>
-          <a:noFill/>
-          <a:ln w="12700">
-            <a:solidFill>
-              <a:prstClr val="black"/>
-            </a:solidFill>
-          </a:ln>
-        </p:spPr>
-        <p:txBody>
-          <a:bodyPr vert="horz" lIns="91440" tIns="45720" rIns="91440" bIns="45720" rtlCol="0" anchor="ctr"/>
-          <a:lstStyle/>
-          <a:p>
-            <a:endParaRPr lang="en-US"/>
-          </a:p>
-        </p:txBody>
-      </p:sp>
-      <p:sp>
-        <p:nvSpPr>
-          <p:cNvPr id="5" name="Notes Placeholder 4"/>
-          <p:cNvSpPr>
-            <a:spLocks noGrp="1"/>
-          </p:cNvSpPr>
-          <p:nvPr>
-            <p:ph type="body" sz="quarter" idx="3"/>
-          </p:nvPr>
-        </p:nvSpPr>
-        <p:spPr>
-          <a:xfrm>
-            <a:off x="685800" y="4400550"/>
-            <a:ext cx="5486400" cy="3600450"/>
-          </a:xfrm>
-          <a:prstGeom prst="rect">
-            <a:avLst/>
-          </a:prstGeom>
-        </p:spPr>
-        <p:txBody>
-          <a:bodyPr vert="horz" lIns="91440" tIns="45720" rIns="91440" bIns="45720" rtlCol="0"/>
-          <a:lstStyle/>
-          <a:p>
-            <a:pPr lvl="0"/>
-            <a:r>
-              <a:rPr lang="en-US"/>
-              <a:t>Click to edit Master text styles</a:t>
-            </a:r>
-          </a:p>
-          <a:p>
-            <a:pPr lvl="1"/>
-            <a:r>
-              <a:rPr lang="en-US"/>
-              <a:t>Second level</a:t>
-            </a:r>
-          </a:p>
-          <a:p>
-            <a:pPr lvl="2"/>
-            <a:r>
-              <a:rPr lang="en-US"/>
-              <a:t>Third level</a:t>
-            </a:r>
-          </a:p>
-          <a:p>
-            <a:pPr lvl="3"/>
-            <a:r>
-              <a:rPr lang="en-US"/>
-              <a:t>Fourth level</a:t>
-            </a:r>
-          </a:p>
-          <a:p>
-            <a:pPr lvl="4"/>
-            <a:r>
-              <a:rPr lang="en-US"/>
-              <a:t>Fifth level</a:t>
-            </a:r>
-          </a:p>
-        </p:txBody>
-      </p:sp>
-      <p:sp>
-        <p:nvSpPr>
-          <p:cNvPr id="6" name="Footer Placeholder 5"/>
-          <p:cNvSpPr>
-            <a:spLocks noGrp="1"/>
-          </p:cNvSpPr>
-          <p:nvPr>
-            <p:ph type="ftr" sz="quarter" idx="4"/>
-          </p:nvPr>
-        </p:nvSpPr>
-        <p:spPr>
-          <a:xfrm>
-            <a:off x="0" y="8685213"/>
-            <a:ext cx="2971800" cy="458787"/>
-          </a:xfrm>
-          <a:prstGeom prst="rect">
-            <a:avLst/>
-          </a:prstGeom>
-        </p:spPr>
-        <p:txBody>
-          <a:bodyPr vert="horz" lIns="91440" tIns="45720" rIns="91440" bIns="45720" rtlCol="0" anchor="b"/>
-          <a:lstStyle>
-            <a:lvl1pPr algn="l">
-              <a:defRPr sz="1200"/>
-            </a:lvl1pPr>
-          </a:lstStyle>
-          <a:p>
-            <a:endParaRPr lang="en-US"/>
-          </a:p>
-        </p:txBody>
-      </p:sp>
-      <p:sp>
-        <p:nvSpPr>
-          <p:cNvPr id="7" name="Slide Number Placeholder 6"/>
-          <p:cNvSpPr>
-            <a:spLocks noGrp="1"/>
-          </p:cNvSpPr>
-          <p:nvPr>
-            <p:ph type="sldNum" sz="quarter" idx="5"/>
-          </p:nvPr>
-        </p:nvSpPr>
-        <p:spPr>
-          <a:xfrm>
-            <a:off x="3884613" y="8685213"/>
-            <a:ext cx="2971800" cy="458787"/>
-          </a:xfrm>
-          <a:prstGeom prst="rect">
-            <a:avLst/>
-          </a:prstGeom>
-        </p:spPr>
-        <p:txBody>
-          <a:bodyPr vert="horz" lIns="91440" tIns="45720" rIns="91440" bIns="45720" rtlCol="0" anchor="b"/>
-          <a:lstStyle>
-            <a:lvl1pPr algn="r">
-              <a:defRPr sz="1200"/>
-            </a:lvl1pPr>
-          </a:lstStyle>
-          <a:p>
-            <a:fld id="{CE5E9CC1-C706-0F49-92D6-E571CC5EEA8F}" type="slidenum">
-              <a:rPr lang="en-US"/>
-              <a:t>‹#›</a:t>
-            </a:fld>
-            <a:endParaRPr lang="en-US"/>
-          </a:p>
-        </p:txBody>
-      </p:sp>
     </p:spTree>
     <p:extLst>
       <p:ext uri="{BB962C8B-B14F-4D97-AF65-F5344CB8AC3E}">
-        <p14:creationId xmlns:p14="http://schemas.microsoft.com/office/powerpoint/2010/main" val="1024086991"/>
+        <p14:creationId xmlns:p14="http://schemas.microsoft.com/office/powerpoint/2010/main" val="2965612987"/>
       </p:ext>
     </p:extLst>
   </p:cSld>
@@ -507,10 +471,6 @@
           <a:bodyPr/>
           <a:lstStyle/>
           <a:p>
-            <a:r>
-              <a:rPr lang="en-US" dirty="0"/>
-              <a:t/>
-            </a:r>
             <a:endParaRPr lang="en-US" dirty="0"/>
           </a:p>
         </p:txBody>
@@ -595,10 +555,6 @@
           <a:bodyPr/>
           <a:lstStyle/>
           <a:p>
-            <a:r>
-              <a:rPr lang="en-US" dirty="0"/>
-              <a:t/>
-            </a:r>
             <a:endParaRPr lang="en-US" dirty="0"/>
           </a:p>
         </p:txBody>
@@ -683,10 +639,6 @@
           <a:bodyPr/>
           <a:lstStyle/>
           <a:p>
-            <a:r>
-              <a:rPr lang="en-US" dirty="0"/>
-              <a:t/>
-            </a:r>
             <a:endParaRPr lang="en-US" dirty="0"/>
           </a:p>
         </p:txBody>
@@ -771,10 +723,6 @@
           <a:bodyPr/>
           <a:lstStyle/>
           <a:p>
-            <a:r>
-              <a:rPr lang="en-US" dirty="0"/>
-              <a:t/>
-            </a:r>
             <a:endParaRPr lang="en-US" dirty="0"/>
           </a:p>
         </p:txBody>
@@ -859,10 +807,6 @@
           <a:bodyPr/>
           <a:lstStyle/>
           <a:p>
-            <a:r>
-              <a:rPr lang="en-US" dirty="0"/>
-              <a:t/>
-            </a:r>
             <a:endParaRPr lang="en-US" dirty="0"/>
           </a:p>
         </p:txBody>
@@ -947,10 +891,6 @@
           <a:bodyPr/>
           <a:lstStyle/>
           <a:p>
-            <a:r>
-              <a:rPr lang="en-US" dirty="0"/>
-              <a:t/>
-            </a:r>
             <a:endParaRPr lang="en-US" dirty="0"/>
           </a:p>
         </p:txBody>
@@ -1035,10 +975,6 @@
           <a:bodyPr/>
           <a:lstStyle/>
           <a:p>
-            <a:r>
-              <a:rPr lang="en-US" dirty="0"/>
-              <a:t/>
-            </a:r>
             <a:endParaRPr lang="en-US" dirty="0"/>
           </a:p>
         </p:txBody>
@@ -1123,10 +1059,6 @@
           <a:bodyPr/>
           <a:lstStyle/>
           <a:p>
-            <a:r>
-              <a:rPr lang="en-US" dirty="0"/>
-              <a:t/>
-            </a:r>
             <a:endParaRPr lang="en-US" dirty="0"/>
           </a:p>
         </p:txBody>
@@ -1200,6 +1132,11 @@
 <file path=ppt/slideMasters/slideMaster1.xml><?xml version="1.0" encoding="utf-8"?>
 <p:sldMaster xmlns:a="http://schemas.openxmlformats.org/drawingml/2006/main" xmlns:r="http://schemas.openxmlformats.org/officeDocument/2006/relationships" xmlns:p="http://schemas.openxmlformats.org/presentationml/2006/main">
   <p:cSld>
+    <p:bg>
+      <p:bgRef idx="1001">
+        <a:schemeClr val="bg1"/>
+      </p:bgRef>
+    </p:bg>
     <p:spTree>
       <p:nvGrpSpPr>
         <p:cNvPr id="1" name=""/>
@@ -1482,6 +1419,7 @@
         <a:solidFill>
           <a:srgbClr val="0D0D0D"/>
         </a:solidFill>
+        <a:effectLst/>
       </p:bgPr>
     </p:bg>
     <p:spTree>
@@ -1522,6 +1460,13 @@
             <a:prstDash val="solid"/>
           </a:ln>
         </p:spPr>
+        <p:txBody>
+          <a:bodyPr/>
+          <a:lstStyle/>
+          <a:p>
+            <a:endParaRPr lang="en-US"/>
+          </a:p>
+        </p:txBody>
       </p:sp>
       <p:sp>
         <p:nvSpPr>
@@ -1544,11 +1489,11 @@
           <a:bodyPr wrap="square" rtlCol="0" anchor="ctr"/>
           <a:lstStyle/>
           <a:p>
-            <a:pPr indent="0" marL="0">
-              <a:buNone/>
-            </a:pPr>
-            <a:r>
-              <a:rPr lang="en-US" sz="900" spc="300" kern="0" dirty="0">
+            <a:pPr marL="0" indent="0">
+              <a:buNone/>
+            </a:pPr>
+            <a:r>
+              <a:rPr lang="en-US" sz="900" kern="0" spc="300" dirty="0">
                 <a:solidFill>
                   <a:srgbClr val="888888"/>
                 </a:solidFill>
@@ -1556,7 +1501,7 @@
                 <a:ea typeface="Consolas" pitchFamily="34" charset="-122"/>
                 <a:cs typeface="Consolas" pitchFamily="34" charset="-120"/>
               </a:rPr>
-              <a:t>CODEALPHA CYBERSECURITY INTERNSHIP  //  2026</a:t>
+              <a:t>CODEALPHA CYBERSECURITY INTERNSHIP (2026)</a:t>
             </a:r>
             <a:endParaRPr lang="en-US" sz="900" dirty="0"/>
           </a:p>
@@ -1583,7 +1528,7 @@
           <a:bodyPr wrap="square" rtlCol="0" anchor="t"/>
           <a:lstStyle/>
           <a:p>
-            <a:pPr indent="0" marL="0">
+            <a:pPr marL="0" indent="0">
               <a:buNone/>
             </a:pPr>
             <a:r>
@@ -1625,6 +1570,13 @@
             <a:prstDash val="solid"/>
           </a:ln>
         </p:spPr>
+        <p:txBody>
+          <a:bodyPr/>
+          <a:lstStyle/>
+          <a:p>
+            <a:endParaRPr lang="en-US"/>
+          </a:p>
+        </p:txBody>
       </p:sp>
       <p:sp>
         <p:nvSpPr>
@@ -1647,7 +1599,7 @@
           <a:bodyPr wrap="square" rtlCol="0" anchor="ctr"/>
           <a:lstStyle/>
           <a:p>
-            <a:pPr indent="0" marL="0">
+            <a:pPr marL="0" indent="0">
               <a:buNone/>
             </a:pPr>
             <a:r>
@@ -1664,7 +1616,7 @@
             <a:endParaRPr lang="en-US" sz="1400" dirty="0"/>
           </a:p>
           <a:p>
-            <a:pPr indent="0" marL="0">
+            <a:pPr marL="0" indent="0">
               <a:buNone/>
             </a:pPr>
             <a:r>
@@ -1706,6 +1658,13 @@
             <a:prstDash val="solid"/>
           </a:ln>
         </p:spPr>
+        <p:txBody>
+          <a:bodyPr/>
+          <a:lstStyle/>
+          <a:p>
+            <a:endParaRPr lang="en-US" dirty="0"/>
+          </a:p>
+        </p:txBody>
       </p:sp>
       <p:sp>
         <p:nvSpPr>
@@ -1728,7 +1687,7 @@
           <a:bodyPr wrap="square" rtlCol="0" anchor="ctr"/>
           <a:lstStyle/>
           <a:p>
-            <a:pPr indent="0" marL="0">
+            <a:pPr marL="0" indent="0">
               <a:buNone/>
             </a:pPr>
             <a:r>
@@ -1767,7 +1726,7 @@
           <a:bodyPr wrap="square" rtlCol="0" anchor="ctr"/>
           <a:lstStyle/>
           <a:p>
-            <a:pPr indent="0" marL="0">
+            <a:pPr marL="0" indent="0">
               <a:buNone/>
             </a:pPr>
             <a:r>
@@ -1809,6 +1768,13 @@
             <a:prstDash val="solid"/>
           </a:ln>
         </p:spPr>
+        <p:txBody>
+          <a:bodyPr/>
+          <a:lstStyle/>
+          <a:p>
+            <a:endParaRPr lang="en-US"/>
+          </a:p>
+        </p:txBody>
       </p:sp>
       <p:sp>
         <p:nvSpPr>
@@ -1831,7 +1797,7 @@
           <a:bodyPr wrap="square" rtlCol="0" anchor="ctr"/>
           <a:lstStyle/>
           <a:p>
-            <a:pPr indent="0" marL="0">
+            <a:pPr marL="0" indent="0">
               <a:buNone/>
             </a:pPr>
             <a:r>
@@ -1870,7 +1836,7 @@
           <a:bodyPr wrap="square" rtlCol="0" anchor="ctr"/>
           <a:lstStyle/>
           <a:p>
-            <a:pPr indent="0" marL="0">
+            <a:pPr marL="0" indent="0">
               <a:buNone/>
             </a:pPr>
             <a:r>
@@ -1912,6 +1878,13 @@
             <a:prstDash val="solid"/>
           </a:ln>
         </p:spPr>
+        <p:txBody>
+          <a:bodyPr/>
+          <a:lstStyle/>
+          <a:p>
+            <a:endParaRPr lang="en-US"/>
+          </a:p>
+        </p:txBody>
       </p:sp>
       <p:sp>
         <p:nvSpPr>
@@ -1934,7 +1907,7 @@
           <a:bodyPr wrap="square" rtlCol="0" anchor="ctr"/>
           <a:lstStyle/>
           <a:p>
-            <a:pPr indent="0" marL="0">
+            <a:pPr marL="0" indent="0">
               <a:buNone/>
             </a:pPr>
             <a:r>
@@ -1973,7 +1946,7 @@
           <a:bodyPr wrap="square" rtlCol="0" anchor="ctr"/>
           <a:lstStyle/>
           <a:p>
-            <a:pPr indent="0" marL="0">
+            <a:pPr marL="0" indent="0">
               <a:buNone/>
             </a:pPr>
             <a:r>
@@ -2012,20 +1985,9 @@
           <a:bodyPr wrap="square" rtlCol="0" anchor="ctr"/>
           <a:lstStyle/>
           <a:p>
-            <a:pPr indent="0" marL="0">
-              <a:buNone/>
-            </a:pPr>
-            <a:r>
-              <a:rPr lang="en-US" sz="900" dirty="0">
-                <a:solidFill>
-                  <a:srgbClr val="444444"/>
-                </a:solidFill>
-                <a:latin typeface="Consolas" pitchFamily="34" charset="0"/>
-                <a:ea typeface="Consolas" pitchFamily="34" charset="-122"/>
-                <a:cs typeface="Consolas" pitchFamily="34" charset="-120"/>
-              </a:rPr>
-              <a:t>Kashaf Noor  ·  GCUF  ·  CodeAlpha Internship</a:t>
-            </a:r>
+            <a:pPr marL="0" indent="0">
+              <a:buNone/>
+            </a:pPr>
             <a:endParaRPr lang="en-US" sz="900" dirty="0"/>
           </a:p>
         </p:txBody>
@@ -2046,6 +2008,7 @@
         <a:solidFill>
           <a:srgbClr val="FFFFFF"/>
         </a:solidFill>
+        <a:effectLst/>
       </p:bgPr>
     </p:bg>
     <p:spTree>
@@ -2086,6 +2049,13 @@
             <a:prstDash val="solid"/>
           </a:ln>
         </p:spPr>
+        <p:txBody>
+          <a:bodyPr/>
+          <a:lstStyle/>
+          <a:p>
+            <a:endParaRPr lang="en-US"/>
+          </a:p>
+        </p:txBody>
       </p:sp>
       <p:sp>
         <p:nvSpPr>
@@ -2108,11 +2078,11 @@
           <a:bodyPr wrap="square" rtlCol="0" anchor="ctr"/>
           <a:lstStyle/>
           <a:p>
-            <a:pPr indent="0" marL="0">
-              <a:buNone/>
-            </a:pPr>
-            <a:r>
-              <a:rPr lang="en-US" sz="900" spc="300" kern="0" dirty="0">
+            <a:pPr marL="0" indent="0">
+              <a:buNone/>
+            </a:pPr>
+            <a:r>
+              <a:rPr lang="en-US" sz="900" kern="0" spc="300" dirty="0">
                 <a:solidFill>
                   <a:srgbClr val="C0392B"/>
                 </a:solidFill>
@@ -2120,7 +2090,7 @@
                 <a:ea typeface="Consolas" pitchFamily="34" charset="-122"/>
                 <a:cs typeface="Consolas" pitchFamily="34" charset="-120"/>
               </a:rPr>
-              <a:t>01 — OVERVIEW</a:t>
+              <a:t>01: OVERVIEW</a:t>
             </a:r>
             <a:endParaRPr lang="en-US" sz="900" dirty="0"/>
           </a:p>
@@ -2147,7 +2117,7 @@
           <a:bodyPr wrap="square" rtlCol="0" anchor="ctr"/>
           <a:lstStyle/>
           <a:p>
-            <a:pPr indent="0" marL="0">
+            <a:pPr marL="0" indent="0">
               <a:buNone/>
             </a:pPr>
             <a:r>
@@ -2189,6 +2159,13 @@
             <a:prstDash val="solid"/>
           </a:ln>
         </p:spPr>
+        <p:txBody>
+          <a:bodyPr/>
+          <a:lstStyle/>
+          <a:p>
+            <a:endParaRPr lang="en-US"/>
+          </a:p>
+        </p:txBody>
       </p:sp>
       <p:sp>
         <p:nvSpPr>
@@ -2214,6 +2191,13 @@
             <a:prstDash val="solid"/>
           </a:ln>
         </p:spPr>
+        <p:txBody>
+          <a:bodyPr/>
+          <a:lstStyle/>
+          <a:p>
+            <a:endParaRPr lang="en-US"/>
+          </a:p>
+        </p:txBody>
       </p:sp>
       <p:sp>
         <p:nvSpPr>
@@ -2236,7 +2220,7 @@
           <a:bodyPr wrap="square" rtlCol="0" anchor="ctr"/>
           <a:lstStyle/>
           <a:p>
-            <a:pPr indent="0" marL="0">
+            <a:pPr marL="0" indent="0">
               <a:buNone/>
             </a:pPr>
             <a:r>
@@ -2253,13 +2237,13 @@
             <a:endParaRPr lang="en-US" sz="1300" dirty="0"/>
           </a:p>
           <a:p>
-            <a:pPr indent="0" marL="0">
+            <a:pPr marL="0" indent="0">
               <a:buNone/>
             </a:pPr>
             <a:endParaRPr lang="en-US" sz="1300" dirty="0"/>
           </a:p>
           <a:p>
-            <a:pPr indent="0" marL="0">
+            <a:pPr marL="0" indent="0">
               <a:buNone/>
             </a:pPr>
             <a:r>
@@ -2271,7 +2255,7 @@
                 <a:ea typeface="Calibri" pitchFamily="34" charset="-122"/>
                 <a:cs typeface="Calibri" pitchFamily="34" charset="-120"/>
               </a:rPr>
-              <a:t>The name comes from "fishing" — attackers cast a wide net hoping victims will "bite."</a:t>
+              <a:t>The name comes from "fishing" where attackers cast a wide net hoping victims will "bite."</a:t>
             </a:r>
             <a:endParaRPr lang="en-US" sz="1300" dirty="0"/>
           </a:p>
@@ -2301,6 +2285,13 @@
             <a:prstDash val="solid"/>
           </a:ln>
         </p:spPr>
+        <p:txBody>
+          <a:bodyPr/>
+          <a:lstStyle/>
+          <a:p>
+            <a:endParaRPr lang="en-US"/>
+          </a:p>
+        </p:txBody>
       </p:sp>
       <p:sp>
         <p:nvSpPr>
@@ -2323,7 +2314,7 @@
           <a:bodyPr wrap="square" rtlCol="0" anchor="ctr"/>
           <a:lstStyle/>
           <a:p>
-            <a:pPr algn="ctr" indent="0" marL="0">
+            <a:pPr marL="0" indent="0" algn="ctr">
               <a:buNone/>
             </a:pPr>
             <a:r>
@@ -2362,7 +2353,7 @@
           <a:bodyPr wrap="square" rtlCol="0" anchor="ctr"/>
           <a:lstStyle/>
           <a:p>
-            <a:pPr indent="0" marL="0">
+            <a:pPr marL="0" indent="0">
               <a:buNone/>
             </a:pPr>
             <a:r>
@@ -2404,6 +2395,13 @@
             <a:prstDash val="solid"/>
           </a:ln>
         </p:spPr>
+        <p:txBody>
+          <a:bodyPr/>
+          <a:lstStyle/>
+          <a:p>
+            <a:endParaRPr lang="en-US"/>
+          </a:p>
+        </p:txBody>
       </p:sp>
       <p:sp>
         <p:nvSpPr>
@@ -2426,7 +2424,7 @@
           <a:bodyPr wrap="square" rtlCol="0" anchor="ctr"/>
           <a:lstStyle/>
           <a:p>
-            <a:pPr algn="ctr" indent="0" marL="0">
+            <a:pPr marL="0" indent="0" algn="ctr">
               <a:buNone/>
             </a:pPr>
             <a:r>
@@ -2465,7 +2463,7 @@
           <a:bodyPr wrap="square" rtlCol="0" anchor="ctr"/>
           <a:lstStyle/>
           <a:p>
-            <a:pPr indent="0" marL="0">
+            <a:pPr marL="0" indent="0">
               <a:buNone/>
             </a:pPr>
             <a:r>
@@ -2507,6 +2505,13 @@
             <a:prstDash val="solid"/>
           </a:ln>
         </p:spPr>
+        <p:txBody>
+          <a:bodyPr/>
+          <a:lstStyle/>
+          <a:p>
+            <a:endParaRPr lang="en-US"/>
+          </a:p>
+        </p:txBody>
       </p:sp>
       <p:sp>
         <p:nvSpPr>
@@ -2529,7 +2534,7 @@
           <a:bodyPr wrap="square" rtlCol="0" anchor="ctr"/>
           <a:lstStyle/>
           <a:p>
-            <a:pPr algn="ctr" indent="0" marL="0">
+            <a:pPr marL="0" indent="0" algn="ctr">
               <a:buNone/>
             </a:pPr>
             <a:r>
@@ -2568,7 +2573,7 @@
           <a:bodyPr wrap="square" rtlCol="0" anchor="ctr"/>
           <a:lstStyle/>
           <a:p>
-            <a:pPr indent="0" marL="0">
+            <a:pPr marL="0" indent="0">
               <a:buNone/>
             </a:pPr>
             <a:r>
@@ -2610,6 +2615,13 @@
             <a:prstDash val="solid"/>
           </a:ln>
         </p:spPr>
+        <p:txBody>
+          <a:bodyPr/>
+          <a:lstStyle/>
+          <a:p>
+            <a:endParaRPr lang="en-US"/>
+          </a:p>
+        </p:txBody>
       </p:sp>
       <p:sp>
         <p:nvSpPr>
@@ -2632,7 +2644,7 @@
           <a:bodyPr wrap="square" rtlCol="0" anchor="ctr"/>
           <a:lstStyle/>
           <a:p>
-            <a:pPr algn="ctr" indent="0" marL="0">
+            <a:pPr marL="0" indent="0" algn="ctr">
               <a:buNone/>
             </a:pPr>
             <a:r>
@@ -2671,7 +2683,7 @@
           <a:bodyPr wrap="square" rtlCol="0" anchor="ctr"/>
           <a:lstStyle/>
           <a:p>
-            <a:pPr indent="0" marL="0">
+            <a:pPr marL="0" indent="0">
               <a:buNone/>
             </a:pPr>
             <a:r>
@@ -2710,7 +2722,7 @@
           <a:bodyPr wrap="square" rtlCol="0" anchor="ctr"/>
           <a:lstStyle/>
           <a:p>
-            <a:pPr indent="0" marL="0">
+            <a:pPr marL="0" indent="0">
               <a:buNone/>
             </a:pPr>
             <a:r>
@@ -2749,7 +2761,7 @@
           <a:bodyPr wrap="square" rtlCol="0" anchor="ctr"/>
           <a:lstStyle/>
           <a:p>
-            <a:pPr indent="0" marL="0">
+            <a:pPr marL="0" indent="0">
               <a:buNone/>
             </a:pPr>
             <a:r>
@@ -2783,6 +2795,7 @@
         <a:solidFill>
           <a:srgbClr val="0D0D0D"/>
         </a:solidFill>
+        <a:effectLst/>
       </p:bgPr>
     </p:bg>
     <p:spTree>
@@ -2823,6 +2836,13 @@
             <a:prstDash val="solid"/>
           </a:ln>
         </p:spPr>
+        <p:txBody>
+          <a:bodyPr/>
+          <a:lstStyle/>
+          <a:p>
+            <a:endParaRPr lang="en-US"/>
+          </a:p>
+        </p:txBody>
       </p:sp>
       <p:sp>
         <p:nvSpPr>
@@ -2845,11 +2865,11 @@
           <a:bodyPr wrap="square" rtlCol="0" anchor="ctr"/>
           <a:lstStyle/>
           <a:p>
-            <a:pPr indent="0" marL="0">
-              <a:buNone/>
-            </a:pPr>
-            <a:r>
-              <a:rPr lang="en-US" sz="900" spc="300" kern="0" dirty="0">
+            <a:pPr marL="0" indent="0">
+              <a:buNone/>
+            </a:pPr>
+            <a:r>
+              <a:rPr lang="en-US" sz="900" kern="0" spc="300" dirty="0">
                 <a:solidFill>
                   <a:srgbClr val="C0392B"/>
                 </a:solidFill>
@@ -2857,7 +2877,7 @@
                 <a:ea typeface="Consolas" pitchFamily="34" charset="-122"/>
                 <a:cs typeface="Consolas" pitchFamily="34" charset="-120"/>
               </a:rPr>
-              <a:t>02 — TYPES</a:t>
+              <a:t>02: TYPES</a:t>
             </a:r>
             <a:endParaRPr lang="en-US" sz="900" dirty="0"/>
           </a:p>
@@ -2884,7 +2904,7 @@
           <a:bodyPr wrap="square" rtlCol="0" anchor="ctr"/>
           <a:lstStyle/>
           <a:p>
-            <a:pPr indent="0" marL="0">
+            <a:pPr marL="0" indent="0">
               <a:buNone/>
             </a:pPr>
             <a:r>
@@ -2926,6 +2946,13 @@
             <a:prstDash val="solid"/>
           </a:ln>
         </p:spPr>
+        <p:txBody>
+          <a:bodyPr/>
+          <a:lstStyle/>
+          <a:p>
+            <a:endParaRPr lang="en-US"/>
+          </a:p>
+        </p:txBody>
       </p:sp>
       <p:sp>
         <p:nvSpPr>
@@ -2951,6 +2978,13 @@
             <a:prstDash val="solid"/>
           </a:ln>
         </p:spPr>
+        <p:txBody>
+          <a:bodyPr/>
+          <a:lstStyle/>
+          <a:p>
+            <a:endParaRPr lang="en-US"/>
+          </a:p>
+        </p:txBody>
       </p:sp>
       <p:sp>
         <p:nvSpPr>
@@ -2973,7 +3007,7 @@
           <a:bodyPr wrap="square" rtlCol="0" anchor="ctr"/>
           <a:lstStyle/>
           <a:p>
-            <a:pPr indent="0" marL="0">
+            <a:pPr marL="0" indent="0">
               <a:buNone/>
             </a:pPr>
             <a:r>
@@ -3009,7 +3043,7 @@
           <a:bodyPr wrap="square" rtlCol="0" anchor="ctr"/>
           <a:lstStyle/>
           <a:p>
-            <a:pPr indent="0" marL="0">
+            <a:pPr marL="0" indent="0">
               <a:buNone/>
             </a:pPr>
             <a:r>
@@ -3048,7 +3082,7 @@
           <a:bodyPr wrap="square" rtlCol="0" anchor="ctr"/>
           <a:lstStyle/>
           <a:p>
-            <a:pPr indent="0" marL="0">
+            <a:pPr marL="0" indent="0">
               <a:buNone/>
             </a:pPr>
             <a:r>
@@ -3090,6 +3124,13 @@
             <a:prstDash val="solid"/>
           </a:ln>
         </p:spPr>
+        <p:txBody>
+          <a:bodyPr/>
+          <a:lstStyle/>
+          <a:p>
+            <a:endParaRPr lang="en-US"/>
+          </a:p>
+        </p:txBody>
       </p:sp>
       <p:sp>
         <p:nvSpPr>
@@ -3115,6 +3156,13 @@
             <a:prstDash val="solid"/>
           </a:ln>
         </p:spPr>
+        <p:txBody>
+          <a:bodyPr/>
+          <a:lstStyle/>
+          <a:p>
+            <a:endParaRPr lang="en-US"/>
+          </a:p>
+        </p:txBody>
       </p:sp>
       <p:sp>
         <p:nvSpPr>
@@ -3137,7 +3185,7 @@
           <a:bodyPr wrap="square" rtlCol="0" anchor="ctr"/>
           <a:lstStyle/>
           <a:p>
-            <a:pPr indent="0" marL="0">
+            <a:pPr marL="0" indent="0">
               <a:buNone/>
             </a:pPr>
             <a:r>
@@ -3173,7 +3221,7 @@
           <a:bodyPr wrap="square" rtlCol="0" anchor="ctr"/>
           <a:lstStyle/>
           <a:p>
-            <a:pPr indent="0" marL="0">
+            <a:pPr marL="0" indent="0">
               <a:buNone/>
             </a:pPr>
             <a:r>
@@ -3212,7 +3260,7 @@
           <a:bodyPr wrap="square" rtlCol="0" anchor="ctr"/>
           <a:lstStyle/>
           <a:p>
-            <a:pPr indent="0" marL="0">
+            <a:pPr marL="0" indent="0">
               <a:buNone/>
             </a:pPr>
             <a:r>
@@ -3254,6 +3302,13 @@
             <a:prstDash val="solid"/>
           </a:ln>
         </p:spPr>
+        <p:txBody>
+          <a:bodyPr/>
+          <a:lstStyle/>
+          <a:p>
+            <a:endParaRPr lang="en-US"/>
+          </a:p>
+        </p:txBody>
       </p:sp>
       <p:sp>
         <p:nvSpPr>
@@ -3279,6 +3334,13 @@
             <a:prstDash val="solid"/>
           </a:ln>
         </p:spPr>
+        <p:txBody>
+          <a:bodyPr/>
+          <a:lstStyle/>
+          <a:p>
+            <a:endParaRPr lang="en-US"/>
+          </a:p>
+        </p:txBody>
       </p:sp>
       <p:sp>
         <p:nvSpPr>
@@ -3301,7 +3363,7 @@
           <a:bodyPr wrap="square" rtlCol="0" anchor="ctr"/>
           <a:lstStyle/>
           <a:p>
-            <a:pPr indent="0" marL="0">
+            <a:pPr marL="0" indent="0">
               <a:buNone/>
             </a:pPr>
             <a:r>
@@ -3337,7 +3399,7 @@
           <a:bodyPr wrap="square" rtlCol="0" anchor="ctr"/>
           <a:lstStyle/>
           <a:p>
-            <a:pPr indent="0" marL="0">
+            <a:pPr marL="0" indent="0">
               <a:buNone/>
             </a:pPr>
             <a:r>
@@ -3376,7 +3438,7 @@
           <a:bodyPr wrap="square" rtlCol="0" anchor="ctr"/>
           <a:lstStyle/>
           <a:p>
-            <a:pPr indent="0" marL="0">
+            <a:pPr marL="0" indent="0">
               <a:buNone/>
             </a:pPr>
             <a:r>
@@ -3418,6 +3480,13 @@
             <a:prstDash val="solid"/>
           </a:ln>
         </p:spPr>
+        <p:txBody>
+          <a:bodyPr/>
+          <a:lstStyle/>
+          <a:p>
+            <a:endParaRPr lang="en-US"/>
+          </a:p>
+        </p:txBody>
       </p:sp>
       <p:sp>
         <p:nvSpPr>
@@ -3443,6 +3512,13 @@
             <a:prstDash val="solid"/>
           </a:ln>
         </p:spPr>
+        <p:txBody>
+          <a:bodyPr/>
+          <a:lstStyle/>
+          <a:p>
+            <a:endParaRPr lang="en-US"/>
+          </a:p>
+        </p:txBody>
       </p:sp>
       <p:sp>
         <p:nvSpPr>
@@ -3465,7 +3541,7 @@
           <a:bodyPr wrap="square" rtlCol="0" anchor="ctr"/>
           <a:lstStyle/>
           <a:p>
-            <a:pPr indent="0" marL="0">
+            <a:pPr marL="0" indent="0">
               <a:buNone/>
             </a:pPr>
             <a:r>
@@ -3501,7 +3577,7 @@
           <a:bodyPr wrap="square" rtlCol="0" anchor="ctr"/>
           <a:lstStyle/>
           <a:p>
-            <a:pPr indent="0" marL="0">
+            <a:pPr marL="0" indent="0">
               <a:buNone/>
             </a:pPr>
             <a:r>
@@ -3540,7 +3616,7 @@
           <a:bodyPr wrap="square" rtlCol="0" anchor="ctr"/>
           <a:lstStyle/>
           <a:p>
-            <a:pPr indent="0" marL="0">
+            <a:pPr marL="0" indent="0">
               <a:buNone/>
             </a:pPr>
             <a:r>
@@ -3582,6 +3658,13 @@
             <a:prstDash val="solid"/>
           </a:ln>
         </p:spPr>
+        <p:txBody>
+          <a:bodyPr/>
+          <a:lstStyle/>
+          <a:p>
+            <a:endParaRPr lang="en-US"/>
+          </a:p>
+        </p:txBody>
       </p:sp>
       <p:sp>
         <p:nvSpPr>
@@ -3607,6 +3690,13 @@
             <a:prstDash val="solid"/>
           </a:ln>
         </p:spPr>
+        <p:txBody>
+          <a:bodyPr/>
+          <a:lstStyle/>
+          <a:p>
+            <a:endParaRPr lang="en-US"/>
+          </a:p>
+        </p:txBody>
       </p:sp>
       <p:sp>
         <p:nvSpPr>
@@ -3629,7 +3719,7 @@
           <a:bodyPr wrap="square" rtlCol="0" anchor="ctr"/>
           <a:lstStyle/>
           <a:p>
-            <a:pPr indent="0" marL="0">
+            <a:pPr marL="0" indent="0">
               <a:buNone/>
             </a:pPr>
             <a:r>
@@ -3665,7 +3755,7 @@
           <a:bodyPr wrap="square" rtlCol="0" anchor="ctr"/>
           <a:lstStyle/>
           <a:p>
-            <a:pPr indent="0" marL="0">
+            <a:pPr marL="0" indent="0">
               <a:buNone/>
             </a:pPr>
             <a:r>
@@ -3704,7 +3794,7 @@
           <a:bodyPr wrap="square" rtlCol="0" anchor="ctr"/>
           <a:lstStyle/>
           <a:p>
-            <a:pPr indent="0" marL="0">
+            <a:pPr marL="0" indent="0">
               <a:buNone/>
             </a:pPr>
             <a:r>
@@ -3746,6 +3836,13 @@
             <a:prstDash val="solid"/>
           </a:ln>
         </p:spPr>
+        <p:txBody>
+          <a:bodyPr/>
+          <a:lstStyle/>
+          <a:p>
+            <a:endParaRPr lang="en-US"/>
+          </a:p>
+        </p:txBody>
       </p:sp>
       <p:sp>
         <p:nvSpPr>
@@ -3771,6 +3868,13 @@
             <a:prstDash val="solid"/>
           </a:ln>
         </p:spPr>
+        <p:txBody>
+          <a:bodyPr/>
+          <a:lstStyle/>
+          <a:p>
+            <a:endParaRPr lang="en-US"/>
+          </a:p>
+        </p:txBody>
       </p:sp>
       <p:sp>
         <p:nvSpPr>
@@ -3793,7 +3897,7 @@
           <a:bodyPr wrap="square" rtlCol="0" anchor="ctr"/>
           <a:lstStyle/>
           <a:p>
-            <a:pPr indent="0" marL="0">
+            <a:pPr marL="0" indent="0">
               <a:buNone/>
             </a:pPr>
             <a:r>
@@ -3829,7 +3933,7 @@
           <a:bodyPr wrap="square" rtlCol="0" anchor="ctr"/>
           <a:lstStyle/>
           <a:p>
-            <a:pPr indent="0" marL="0">
+            <a:pPr marL="0" indent="0">
               <a:buNone/>
             </a:pPr>
             <a:r>
@@ -3868,7 +3972,7 @@
           <a:bodyPr wrap="square" rtlCol="0" anchor="ctr"/>
           <a:lstStyle/>
           <a:p>
-            <a:pPr indent="0" marL="0">
+            <a:pPr marL="0" indent="0">
               <a:buNone/>
             </a:pPr>
             <a:r>
@@ -3902,6 +4006,7 @@
         <a:solidFill>
           <a:srgbClr val="FFFFFF"/>
         </a:solidFill>
+        <a:effectLst/>
       </p:bgPr>
     </p:bg>
     <p:spTree>
@@ -3942,6 +4047,13 @@
             <a:prstDash val="solid"/>
           </a:ln>
         </p:spPr>
+        <p:txBody>
+          <a:bodyPr/>
+          <a:lstStyle/>
+          <a:p>
+            <a:endParaRPr lang="en-US"/>
+          </a:p>
+        </p:txBody>
       </p:sp>
       <p:sp>
         <p:nvSpPr>
@@ -3964,11 +4076,11 @@
           <a:bodyPr wrap="square" rtlCol="0" anchor="ctr"/>
           <a:lstStyle/>
           <a:p>
-            <a:pPr indent="0" marL="0">
-              <a:buNone/>
-            </a:pPr>
-            <a:r>
-              <a:rPr lang="en-US" sz="900" spc="300" kern="0" dirty="0">
+            <a:pPr marL="0" indent="0">
+              <a:buNone/>
+            </a:pPr>
+            <a:r>
+              <a:rPr lang="en-US" sz="900" kern="0" spc="300" dirty="0">
                 <a:solidFill>
                   <a:srgbClr val="C0392B"/>
                 </a:solidFill>
@@ -3976,7 +4088,7 @@
                 <a:ea typeface="Consolas" pitchFamily="34" charset="-122"/>
                 <a:cs typeface="Consolas" pitchFamily="34" charset="-120"/>
               </a:rPr>
-              <a:t>03 — RECOGNITION</a:t>
+              <a:t>03: RECOGNITION</a:t>
             </a:r>
             <a:endParaRPr lang="en-US" sz="900" dirty="0"/>
           </a:p>
@@ -4003,7 +4115,7 @@
           <a:bodyPr wrap="square" rtlCol="0" anchor="ctr"/>
           <a:lstStyle/>
           <a:p>
-            <a:pPr indent="0" marL="0">
+            <a:pPr marL="0" indent="0">
               <a:buNone/>
             </a:pPr>
             <a:r>
@@ -4045,6 +4157,13 @@
             <a:prstDash val="solid"/>
           </a:ln>
         </p:spPr>
+        <p:txBody>
+          <a:bodyPr/>
+          <a:lstStyle/>
+          <a:p>
+            <a:endParaRPr lang="en-US"/>
+          </a:p>
+        </p:txBody>
       </p:sp>
       <p:sp>
         <p:nvSpPr>
@@ -4070,6 +4189,13 @@
             <a:prstDash val="solid"/>
           </a:ln>
         </p:spPr>
+        <p:txBody>
+          <a:bodyPr/>
+          <a:lstStyle/>
+          <a:p>
+            <a:endParaRPr lang="en-US"/>
+          </a:p>
+        </p:txBody>
       </p:sp>
       <p:sp>
         <p:nvSpPr>
@@ -4092,7 +4218,7 @@
           <a:bodyPr wrap="square" rtlCol="0" anchor="ctr"/>
           <a:lstStyle/>
           <a:p>
-            <a:pPr indent="0" marL="0">
+            <a:pPr marL="0" indent="0">
               <a:buNone/>
             </a:pPr>
             <a:r>
@@ -4131,7 +4257,7 @@
           <a:bodyPr wrap="square" rtlCol="0" anchor="ctr"/>
           <a:lstStyle/>
           <a:p>
-            <a:pPr indent="0" marL="0">
+            <a:pPr marL="0" indent="0">
               <a:buNone/>
             </a:pPr>
             <a:r>
@@ -4173,6 +4299,13 @@
             <a:prstDash val="solid"/>
           </a:ln>
         </p:spPr>
+        <p:txBody>
+          <a:bodyPr/>
+          <a:lstStyle/>
+          <a:p>
+            <a:endParaRPr lang="en-US"/>
+          </a:p>
+        </p:txBody>
       </p:sp>
       <p:sp>
         <p:nvSpPr>
@@ -4198,6 +4331,13 @@
             <a:prstDash val="solid"/>
           </a:ln>
         </p:spPr>
+        <p:txBody>
+          <a:bodyPr/>
+          <a:lstStyle/>
+          <a:p>
+            <a:endParaRPr lang="en-US"/>
+          </a:p>
+        </p:txBody>
       </p:sp>
       <p:sp>
         <p:nvSpPr>
@@ -4220,7 +4360,7 @@
           <a:bodyPr wrap="square" rtlCol="0" anchor="ctr"/>
           <a:lstStyle/>
           <a:p>
-            <a:pPr indent="0" marL="0">
+            <a:pPr marL="0" indent="0">
               <a:buNone/>
             </a:pPr>
             <a:r>
@@ -4259,7 +4399,7 @@
           <a:bodyPr wrap="square" rtlCol="0" anchor="ctr"/>
           <a:lstStyle/>
           <a:p>
-            <a:pPr indent="0" marL="0">
+            <a:pPr marL="0" indent="0">
               <a:buNone/>
             </a:pPr>
             <a:r>
@@ -4301,6 +4441,13 @@
             <a:prstDash val="solid"/>
           </a:ln>
         </p:spPr>
+        <p:txBody>
+          <a:bodyPr/>
+          <a:lstStyle/>
+          <a:p>
+            <a:endParaRPr lang="en-US"/>
+          </a:p>
+        </p:txBody>
       </p:sp>
       <p:sp>
         <p:nvSpPr>
@@ -4326,6 +4473,13 @@
             <a:prstDash val="solid"/>
           </a:ln>
         </p:spPr>
+        <p:txBody>
+          <a:bodyPr/>
+          <a:lstStyle/>
+          <a:p>
+            <a:endParaRPr lang="en-US"/>
+          </a:p>
+        </p:txBody>
       </p:sp>
       <p:sp>
         <p:nvSpPr>
@@ -4348,7 +4502,7 @@
           <a:bodyPr wrap="square" rtlCol="0" anchor="ctr"/>
           <a:lstStyle/>
           <a:p>
-            <a:pPr indent="0" marL="0">
+            <a:pPr marL="0" indent="0">
               <a:buNone/>
             </a:pPr>
             <a:r>
@@ -4387,7 +4541,7 @@
           <a:bodyPr wrap="square" rtlCol="0" anchor="ctr"/>
           <a:lstStyle/>
           <a:p>
-            <a:pPr indent="0" marL="0">
+            <a:pPr marL="0" indent="0">
               <a:buNone/>
             </a:pPr>
             <a:r>
@@ -4429,6 +4583,13 @@
             <a:prstDash val="solid"/>
           </a:ln>
         </p:spPr>
+        <p:txBody>
+          <a:bodyPr/>
+          <a:lstStyle/>
+          <a:p>
+            <a:endParaRPr lang="en-US"/>
+          </a:p>
+        </p:txBody>
       </p:sp>
       <p:sp>
         <p:nvSpPr>
@@ -4454,6 +4615,13 @@
             <a:prstDash val="solid"/>
           </a:ln>
         </p:spPr>
+        <p:txBody>
+          <a:bodyPr/>
+          <a:lstStyle/>
+          <a:p>
+            <a:endParaRPr lang="en-US"/>
+          </a:p>
+        </p:txBody>
       </p:sp>
       <p:sp>
         <p:nvSpPr>
@@ -4476,7 +4644,7 @@
           <a:bodyPr wrap="square" rtlCol="0" anchor="ctr"/>
           <a:lstStyle/>
           <a:p>
-            <a:pPr indent="0" marL="0">
+            <a:pPr marL="0" indent="0">
               <a:buNone/>
             </a:pPr>
             <a:r>
@@ -4515,7 +4683,7 @@
           <a:bodyPr wrap="square" rtlCol="0" anchor="ctr"/>
           <a:lstStyle/>
           <a:p>
-            <a:pPr indent="0" marL="0">
+            <a:pPr marL="0" indent="0">
               <a:buNone/>
             </a:pPr>
             <a:r>
@@ -4557,6 +4725,13 @@
             <a:prstDash val="solid"/>
           </a:ln>
         </p:spPr>
+        <p:txBody>
+          <a:bodyPr/>
+          <a:lstStyle/>
+          <a:p>
+            <a:endParaRPr lang="en-US"/>
+          </a:p>
+        </p:txBody>
       </p:sp>
       <p:sp>
         <p:nvSpPr>
@@ -4582,6 +4757,13 @@
             <a:prstDash val="solid"/>
           </a:ln>
         </p:spPr>
+        <p:txBody>
+          <a:bodyPr/>
+          <a:lstStyle/>
+          <a:p>
+            <a:endParaRPr lang="en-US"/>
+          </a:p>
+        </p:txBody>
       </p:sp>
       <p:sp>
         <p:nvSpPr>
@@ -4604,7 +4786,7 @@
           <a:bodyPr wrap="square" rtlCol="0" anchor="ctr"/>
           <a:lstStyle/>
           <a:p>
-            <a:pPr indent="0" marL="0">
+            <a:pPr marL="0" indent="0">
               <a:buNone/>
             </a:pPr>
             <a:r>
@@ -4643,7 +4825,7 @@
           <a:bodyPr wrap="square" rtlCol="0" anchor="ctr"/>
           <a:lstStyle/>
           <a:p>
-            <a:pPr indent="0" marL="0">
+            <a:pPr marL="0" indent="0">
               <a:buNone/>
             </a:pPr>
             <a:r>
@@ -4685,6 +4867,13 @@
             <a:prstDash val="solid"/>
           </a:ln>
         </p:spPr>
+        <p:txBody>
+          <a:bodyPr/>
+          <a:lstStyle/>
+          <a:p>
+            <a:endParaRPr lang="en-US"/>
+          </a:p>
+        </p:txBody>
       </p:sp>
       <p:sp>
         <p:nvSpPr>
@@ -4710,6 +4899,13 @@
             <a:prstDash val="solid"/>
           </a:ln>
         </p:spPr>
+        <p:txBody>
+          <a:bodyPr/>
+          <a:lstStyle/>
+          <a:p>
+            <a:endParaRPr lang="en-US"/>
+          </a:p>
+        </p:txBody>
       </p:sp>
       <p:sp>
         <p:nvSpPr>
@@ -4732,7 +4928,7 @@
           <a:bodyPr wrap="square" rtlCol="0" anchor="ctr"/>
           <a:lstStyle/>
           <a:p>
-            <a:pPr indent="0" marL="0">
+            <a:pPr marL="0" indent="0">
               <a:buNone/>
             </a:pPr>
             <a:r>
@@ -4771,7 +4967,7 @@
           <a:bodyPr wrap="square" rtlCol="0" anchor="ctr"/>
           <a:lstStyle/>
           <a:p>
-            <a:pPr indent="0" marL="0">
+            <a:pPr marL="0" indent="0">
               <a:buNone/>
             </a:pPr>
             <a:r>
@@ -4813,6 +5009,13 @@
             <a:prstDash val="solid"/>
           </a:ln>
         </p:spPr>
+        <p:txBody>
+          <a:bodyPr/>
+          <a:lstStyle/>
+          <a:p>
+            <a:endParaRPr lang="en-US"/>
+          </a:p>
+        </p:txBody>
       </p:sp>
       <p:sp>
         <p:nvSpPr>
@@ -4838,6 +5041,13 @@
             <a:prstDash val="solid"/>
           </a:ln>
         </p:spPr>
+        <p:txBody>
+          <a:bodyPr/>
+          <a:lstStyle/>
+          <a:p>
+            <a:endParaRPr lang="en-US"/>
+          </a:p>
+        </p:txBody>
       </p:sp>
       <p:sp>
         <p:nvSpPr>
@@ -4860,7 +5070,7 @@
           <a:bodyPr wrap="square" rtlCol="0" anchor="ctr"/>
           <a:lstStyle/>
           <a:p>
-            <a:pPr indent="0" marL="0">
+            <a:pPr marL="0" indent="0">
               <a:buNone/>
             </a:pPr>
             <a:r>
@@ -4899,7 +5109,7 @@
           <a:bodyPr wrap="square" rtlCol="0" anchor="ctr"/>
           <a:lstStyle/>
           <a:p>
-            <a:pPr indent="0" marL="0">
+            <a:pPr marL="0" indent="0">
               <a:buNone/>
             </a:pPr>
             <a:r>
@@ -4941,6 +5151,13 @@
             <a:prstDash val="solid"/>
           </a:ln>
         </p:spPr>
+        <p:txBody>
+          <a:bodyPr/>
+          <a:lstStyle/>
+          <a:p>
+            <a:endParaRPr lang="en-US"/>
+          </a:p>
+        </p:txBody>
       </p:sp>
       <p:sp>
         <p:nvSpPr>
@@ -4966,6 +5183,13 @@
             <a:prstDash val="solid"/>
           </a:ln>
         </p:spPr>
+        <p:txBody>
+          <a:bodyPr/>
+          <a:lstStyle/>
+          <a:p>
+            <a:endParaRPr lang="en-US"/>
+          </a:p>
+        </p:txBody>
       </p:sp>
       <p:sp>
         <p:nvSpPr>
@@ -4988,7 +5212,7 @@
           <a:bodyPr wrap="square" rtlCol="0" anchor="ctr"/>
           <a:lstStyle/>
           <a:p>
-            <a:pPr indent="0" marL="0">
+            <a:pPr marL="0" indent="0">
               <a:buNone/>
             </a:pPr>
             <a:r>
@@ -5027,7 +5251,7 @@
           <a:bodyPr wrap="square" rtlCol="0" anchor="ctr"/>
           <a:lstStyle/>
           <a:p>
-            <a:pPr indent="0" marL="0">
+            <a:pPr marL="0" indent="0">
               <a:buNone/>
             </a:pPr>
             <a:r>
@@ -5069,6 +5293,13 @@
             <a:prstDash val="solid"/>
           </a:ln>
         </p:spPr>
+        <p:txBody>
+          <a:bodyPr/>
+          <a:lstStyle/>
+          <a:p>
+            <a:endParaRPr lang="en-US"/>
+          </a:p>
+        </p:txBody>
       </p:sp>
       <p:sp>
         <p:nvSpPr>
@@ -5094,6 +5325,13 @@
             <a:prstDash val="solid"/>
           </a:ln>
         </p:spPr>
+        <p:txBody>
+          <a:bodyPr/>
+          <a:lstStyle/>
+          <a:p>
+            <a:endParaRPr lang="en-US"/>
+          </a:p>
+        </p:txBody>
       </p:sp>
       <p:sp>
         <p:nvSpPr>
@@ -5116,7 +5354,7 @@
           <a:bodyPr wrap="square" rtlCol="0" anchor="ctr"/>
           <a:lstStyle/>
           <a:p>
-            <a:pPr indent="0" marL="0">
+            <a:pPr marL="0" indent="0">
               <a:buNone/>
             </a:pPr>
             <a:r>
@@ -5155,7 +5393,7 @@
           <a:bodyPr wrap="square" rtlCol="0" anchor="ctr"/>
           <a:lstStyle/>
           <a:p>
-            <a:pPr indent="0" marL="0">
+            <a:pPr marL="0" indent="0">
               <a:buNone/>
             </a:pPr>
             <a:r>
@@ -5167,7 +5405,7 @@
                 <a:ea typeface="Calibri" pitchFamily="34" charset="-122"/>
                 <a:cs typeface="Calibri" pitchFamily="34" charset="-120"/>
               </a:rPr>
-              <a:t>Mismatched branding — logos look slightly off</a:t>
+              <a:t>Mismatched branding , logos look slightly off</a:t>
             </a:r>
             <a:endParaRPr lang="en-US" sz="1050" dirty="0"/>
           </a:p>
@@ -5197,6 +5435,13 @@
             <a:prstDash val="solid"/>
           </a:ln>
         </p:spPr>
+        <p:txBody>
+          <a:bodyPr/>
+          <a:lstStyle/>
+          <a:p>
+            <a:endParaRPr lang="en-US"/>
+          </a:p>
+        </p:txBody>
       </p:sp>
       <p:sp>
         <p:nvSpPr>
@@ -5222,6 +5467,13 @@
             <a:prstDash val="solid"/>
           </a:ln>
         </p:spPr>
+        <p:txBody>
+          <a:bodyPr/>
+          <a:lstStyle/>
+          <a:p>
+            <a:endParaRPr lang="en-US"/>
+          </a:p>
+        </p:txBody>
       </p:sp>
       <p:sp>
         <p:nvSpPr>
@@ -5244,7 +5496,7 @@
           <a:bodyPr wrap="square" rtlCol="0" anchor="ctr"/>
           <a:lstStyle/>
           <a:p>
-            <a:pPr indent="0" marL="0">
+            <a:pPr marL="0" indent="0">
               <a:buNone/>
             </a:pPr>
             <a:r>
@@ -5283,7 +5535,7 @@
           <a:bodyPr wrap="square" rtlCol="0" anchor="ctr"/>
           <a:lstStyle/>
           <a:p>
-            <a:pPr indent="0" marL="0">
+            <a:pPr marL="0" indent="0">
               <a:buNone/>
             </a:pPr>
             <a:r>
@@ -5317,6 +5569,7 @@
         <a:solidFill>
           <a:srgbClr val="0D0D0D"/>
         </a:solidFill>
+        <a:effectLst/>
       </p:bgPr>
     </p:bg>
     <p:spTree>
@@ -5357,6 +5610,13 @@
             <a:prstDash val="solid"/>
           </a:ln>
         </p:spPr>
+        <p:txBody>
+          <a:bodyPr/>
+          <a:lstStyle/>
+          <a:p>
+            <a:endParaRPr lang="en-US"/>
+          </a:p>
+        </p:txBody>
       </p:sp>
       <p:sp>
         <p:nvSpPr>
@@ -5379,11 +5639,11 @@
           <a:bodyPr wrap="square" rtlCol="0" anchor="ctr"/>
           <a:lstStyle/>
           <a:p>
-            <a:pPr indent="0" marL="0">
-              <a:buNone/>
-            </a:pPr>
-            <a:r>
-              <a:rPr lang="en-US" sz="900" spc="300" kern="0" dirty="0">
+            <a:pPr marL="0" indent="0">
+              <a:buNone/>
+            </a:pPr>
+            <a:r>
+              <a:rPr lang="en-US" sz="900" kern="0" spc="300" dirty="0">
                 <a:solidFill>
                   <a:srgbClr val="C0392B"/>
                 </a:solidFill>
@@ -5391,7 +5651,7 @@
                 <a:ea typeface="Consolas" pitchFamily="34" charset="-122"/>
                 <a:cs typeface="Consolas" pitchFamily="34" charset="-120"/>
               </a:rPr>
-              <a:t>04 — CASE STUDIES</a:t>
+              <a:t>04: CASE STUDIES</a:t>
             </a:r>
             <a:endParaRPr lang="en-US" sz="900" dirty="0"/>
           </a:p>
@@ -5418,7 +5678,7 @@
           <a:bodyPr wrap="square" rtlCol="0" anchor="ctr"/>
           <a:lstStyle/>
           <a:p>
-            <a:pPr indent="0" marL="0">
+            <a:pPr marL="0" indent="0">
               <a:buNone/>
             </a:pPr>
             <a:r>
@@ -5460,6 +5720,13 @@
             <a:prstDash val="solid"/>
           </a:ln>
         </p:spPr>
+        <p:txBody>
+          <a:bodyPr/>
+          <a:lstStyle/>
+          <a:p>
+            <a:endParaRPr lang="en-US"/>
+          </a:p>
+        </p:txBody>
       </p:sp>
       <p:sp>
         <p:nvSpPr>
@@ -5485,6 +5752,13 @@
             <a:prstDash val="solid"/>
           </a:ln>
         </p:spPr>
+        <p:txBody>
+          <a:bodyPr/>
+          <a:lstStyle/>
+          <a:p>
+            <a:endParaRPr lang="en-US"/>
+          </a:p>
+        </p:txBody>
       </p:sp>
       <p:sp>
         <p:nvSpPr>
@@ -5507,11 +5781,11 @@
           <a:bodyPr wrap="square" rtlCol="0" anchor="ctr"/>
           <a:lstStyle/>
           <a:p>
-            <a:pPr indent="0" marL="0">
-              <a:buNone/>
-            </a:pPr>
-            <a:r>
-              <a:rPr lang="en-US" sz="850" spc="200" kern="0" dirty="0">
+            <a:pPr marL="0" indent="0">
+              <a:buNone/>
+            </a:pPr>
+            <a:r>
+              <a:rPr lang="en-US" sz="850" kern="0" spc="200" dirty="0">
                 <a:solidFill>
                   <a:srgbClr val="C0392B"/>
                 </a:solidFill>
@@ -5546,7 +5820,7 @@
           <a:bodyPr wrap="square" rtlCol="0" anchor="ctr"/>
           <a:lstStyle/>
           <a:p>
-            <a:pPr indent="0" marL="0">
+            <a:pPr marL="0" indent="0">
               <a:buNone/>
             </a:pPr>
             <a:r>
@@ -5588,6 +5862,13 @@
             <a:prstDash val="solid"/>
           </a:ln>
         </p:spPr>
+        <p:txBody>
+          <a:bodyPr/>
+          <a:lstStyle/>
+          <a:p>
+            <a:endParaRPr lang="en-US"/>
+          </a:p>
+        </p:txBody>
       </p:sp>
       <p:sp>
         <p:nvSpPr>
@@ -5610,7 +5891,7 @@
           <a:bodyPr wrap="square" rtlCol="0" anchor="ctr"/>
           <a:lstStyle/>
           <a:p>
-            <a:pPr indent="0" marL="0">
+            <a:pPr marL="0" indent="0">
               <a:buNone/>
             </a:pPr>
             <a:r>
@@ -5652,6 +5933,13 @@
             <a:prstDash val="solid"/>
           </a:ln>
         </p:spPr>
+        <p:txBody>
+          <a:bodyPr/>
+          <a:lstStyle/>
+          <a:p>
+            <a:endParaRPr lang="en-US"/>
+          </a:p>
+        </p:txBody>
       </p:sp>
       <p:sp>
         <p:nvSpPr>
@@ -5674,7 +5962,7 @@
           <a:bodyPr wrap="square" rtlCol="0" anchor="ctr"/>
           <a:lstStyle/>
           <a:p>
-            <a:pPr indent="0" marL="0">
+            <a:pPr marL="0" indent="0">
               <a:buNone/>
             </a:pPr>
             <a:r>
@@ -5716,6 +6004,13 @@
             <a:prstDash val="solid"/>
           </a:ln>
         </p:spPr>
+        <p:txBody>
+          <a:bodyPr/>
+          <a:lstStyle/>
+          <a:p>
+            <a:endParaRPr lang="en-US"/>
+          </a:p>
+        </p:txBody>
       </p:sp>
       <p:sp>
         <p:nvSpPr>
@@ -5741,6 +6036,13 @@
             <a:prstDash val="solid"/>
           </a:ln>
         </p:spPr>
+        <p:txBody>
+          <a:bodyPr/>
+          <a:lstStyle/>
+          <a:p>
+            <a:endParaRPr lang="en-US"/>
+          </a:p>
+        </p:txBody>
       </p:sp>
       <p:sp>
         <p:nvSpPr>
@@ -5763,11 +6065,11 @@
           <a:bodyPr wrap="square" rtlCol="0" anchor="ctr"/>
           <a:lstStyle/>
           <a:p>
-            <a:pPr indent="0" marL="0">
-              <a:buNone/>
-            </a:pPr>
-            <a:r>
-              <a:rPr lang="en-US" sz="850" spc="200" kern="0" dirty="0">
+            <a:pPr marL="0" indent="0">
+              <a:buNone/>
+            </a:pPr>
+            <a:r>
+              <a:rPr lang="en-US" sz="850" kern="0" spc="200" dirty="0">
                 <a:solidFill>
                   <a:srgbClr val="C0392B"/>
                 </a:solidFill>
@@ -5802,7 +6104,7 @@
           <a:bodyPr wrap="square" rtlCol="0" anchor="ctr"/>
           <a:lstStyle/>
           <a:p>
-            <a:pPr indent="0" marL="0">
+            <a:pPr marL="0" indent="0">
               <a:buNone/>
             </a:pPr>
             <a:r>
@@ -5814,7 +6116,7 @@
                 <a:ea typeface="Georgia" pitchFamily="34" charset="-122"/>
                 <a:cs typeface="Georgia" pitchFamily="34" charset="-120"/>
               </a:rPr>
-              <a:t>Google &amp; Facebook — $100M</a:t>
+              <a:t>Google &amp; Facebook: $100M</a:t>
             </a:r>
             <a:endParaRPr lang="en-US" sz="1350" dirty="0"/>
           </a:p>
@@ -5844,6 +6146,13 @@
             <a:prstDash val="solid"/>
           </a:ln>
         </p:spPr>
+        <p:txBody>
+          <a:bodyPr/>
+          <a:lstStyle/>
+          <a:p>
+            <a:endParaRPr lang="en-US"/>
+          </a:p>
+        </p:txBody>
       </p:sp>
       <p:sp>
         <p:nvSpPr>
@@ -5866,7 +6175,7 @@
           <a:bodyPr wrap="square" rtlCol="0" anchor="ctr"/>
           <a:lstStyle/>
           <a:p>
-            <a:pPr indent="0" marL="0">
+            <a:pPr marL="0" indent="0">
               <a:buNone/>
             </a:pPr>
             <a:r>
@@ -5908,6 +6217,13 @@
             <a:prstDash val="solid"/>
           </a:ln>
         </p:spPr>
+        <p:txBody>
+          <a:bodyPr/>
+          <a:lstStyle/>
+          <a:p>
+            <a:endParaRPr lang="en-US"/>
+          </a:p>
+        </p:txBody>
       </p:sp>
       <p:sp>
         <p:nvSpPr>
@@ -5930,7 +6246,7 @@
           <a:bodyPr wrap="square" rtlCol="0" anchor="ctr"/>
           <a:lstStyle/>
           <a:p>
-            <a:pPr indent="0" marL="0">
+            <a:pPr marL="0" indent="0">
               <a:buNone/>
             </a:pPr>
             <a:r>
@@ -5972,6 +6288,13 @@
             <a:prstDash val="solid"/>
           </a:ln>
         </p:spPr>
+        <p:txBody>
+          <a:bodyPr/>
+          <a:lstStyle/>
+          <a:p>
+            <a:endParaRPr lang="en-US"/>
+          </a:p>
+        </p:txBody>
       </p:sp>
       <p:sp>
         <p:nvSpPr>
@@ -5997,6 +6320,13 @@
             <a:prstDash val="solid"/>
           </a:ln>
         </p:spPr>
+        <p:txBody>
+          <a:bodyPr/>
+          <a:lstStyle/>
+          <a:p>
+            <a:endParaRPr lang="en-US"/>
+          </a:p>
+        </p:txBody>
       </p:sp>
       <p:sp>
         <p:nvSpPr>
@@ -6019,11 +6349,11 @@
           <a:bodyPr wrap="square" rtlCol="0" anchor="ctr"/>
           <a:lstStyle/>
           <a:p>
-            <a:pPr indent="0" marL="0">
-              <a:buNone/>
-            </a:pPr>
-            <a:r>
-              <a:rPr lang="en-US" sz="850" spc="200" kern="0" dirty="0">
+            <a:pPr marL="0" indent="0">
+              <a:buNone/>
+            </a:pPr>
+            <a:r>
+              <a:rPr lang="en-US" sz="850" kern="0" spc="200" dirty="0">
                 <a:solidFill>
                   <a:srgbClr val="C0392B"/>
                 </a:solidFill>
@@ -6058,7 +6388,7 @@
           <a:bodyPr wrap="square" rtlCol="0" anchor="ctr"/>
           <a:lstStyle/>
           <a:p>
-            <a:pPr indent="0" marL="0">
+            <a:pPr marL="0" indent="0">
               <a:buNone/>
             </a:pPr>
             <a:r>
@@ -6100,6 +6430,13 @@
             <a:prstDash val="solid"/>
           </a:ln>
         </p:spPr>
+        <p:txBody>
+          <a:bodyPr/>
+          <a:lstStyle/>
+          <a:p>
+            <a:endParaRPr lang="en-US"/>
+          </a:p>
+        </p:txBody>
       </p:sp>
       <p:sp>
         <p:nvSpPr>
@@ -6122,7 +6459,7 @@
           <a:bodyPr wrap="square" rtlCol="0" anchor="ctr"/>
           <a:lstStyle/>
           <a:p>
-            <a:pPr indent="0" marL="0">
+            <a:pPr marL="0" indent="0">
               <a:buNone/>
             </a:pPr>
             <a:r>
@@ -6134,7 +6471,7 @@
                 <a:ea typeface="Calibri" pitchFamily="34" charset="-122"/>
                 <a:cs typeface="Calibri" pitchFamily="34" charset="-120"/>
               </a:rPr>
-              <a:t>Customers got SMS messages claiming accounts were blocked. Attackers posing as bank agents collected OTPs and drained accounts — a smishing + vishing combo attack.</a:t>
+              <a:t>Customers got SMS messages claiming accounts were blocked. Attackers posing as bank agents collected OTPs and drained accounts ,a smishing + vishing combo attack.</a:t>
             </a:r>
             <a:endParaRPr lang="en-US" sz="1000" dirty="0"/>
           </a:p>
@@ -6164,6 +6501,13 @@
             <a:prstDash val="solid"/>
           </a:ln>
         </p:spPr>
+        <p:txBody>
+          <a:bodyPr/>
+          <a:lstStyle/>
+          <a:p>
+            <a:endParaRPr lang="en-US"/>
+          </a:p>
+        </p:txBody>
       </p:sp>
       <p:sp>
         <p:nvSpPr>
@@ -6186,7 +6530,7 @@
           <a:bodyPr wrap="square" rtlCol="0" anchor="ctr"/>
           <a:lstStyle/>
           <a:p>
-            <a:pPr indent="0" marL="0">
+            <a:pPr marL="0" indent="0">
               <a:buNone/>
             </a:pPr>
             <a:r>
@@ -6220,6 +6564,7 @@
         <a:solidFill>
           <a:srgbClr val="FFFFFF"/>
         </a:solidFill>
+        <a:effectLst/>
       </p:bgPr>
     </p:bg>
     <p:spTree>
@@ -6260,6 +6605,13 @@
             <a:prstDash val="solid"/>
           </a:ln>
         </p:spPr>
+        <p:txBody>
+          <a:bodyPr/>
+          <a:lstStyle/>
+          <a:p>
+            <a:endParaRPr lang="en-US"/>
+          </a:p>
+        </p:txBody>
       </p:sp>
       <p:sp>
         <p:nvSpPr>
@@ -6282,11 +6634,11 @@
           <a:bodyPr wrap="square" rtlCol="0" anchor="ctr"/>
           <a:lstStyle/>
           <a:p>
-            <a:pPr indent="0" marL="0">
-              <a:buNone/>
-            </a:pPr>
-            <a:r>
-              <a:rPr lang="en-US" sz="900" spc="300" kern="0" dirty="0">
+            <a:pPr marL="0" indent="0">
+              <a:buNone/>
+            </a:pPr>
+            <a:r>
+              <a:rPr lang="en-US" sz="900" kern="0" spc="300" dirty="0">
                 <a:solidFill>
                   <a:srgbClr val="C0392B"/>
                 </a:solidFill>
@@ -6294,7 +6646,7 @@
                 <a:ea typeface="Consolas" pitchFamily="34" charset="-122"/>
                 <a:cs typeface="Consolas" pitchFamily="34" charset="-120"/>
               </a:rPr>
-              <a:t>05 — DEFENSE</a:t>
+              <a:t>05: DEFENSE</a:t>
             </a:r>
             <a:endParaRPr lang="en-US" sz="900" dirty="0"/>
           </a:p>
@@ -6321,7 +6673,7 @@
           <a:bodyPr wrap="square" rtlCol="0" anchor="ctr"/>
           <a:lstStyle/>
           <a:p>
-            <a:pPr indent="0" marL="0">
+            <a:pPr marL="0" indent="0">
               <a:buNone/>
             </a:pPr>
             <a:r>
@@ -6363,6 +6715,13 @@
             <a:prstDash val="solid"/>
           </a:ln>
         </p:spPr>
+        <p:txBody>
+          <a:bodyPr/>
+          <a:lstStyle/>
+          <a:p>
+            <a:endParaRPr lang="en-US"/>
+          </a:p>
+        </p:txBody>
       </p:sp>
       <p:sp>
         <p:nvSpPr>
@@ -6385,7 +6744,7 @@
           <a:bodyPr wrap="square" rtlCol="0" anchor="ctr"/>
           <a:lstStyle/>
           <a:p>
-            <a:pPr indent="0" marL="0">
+            <a:pPr marL="0" indent="0">
               <a:buNone/>
             </a:pPr>
             <a:r>
@@ -6424,7 +6783,7 @@
           <a:bodyPr wrap="square" rtlCol="0" anchor="ctr"/>
           <a:lstStyle/>
           <a:p>
-            <a:pPr indent="0" marL="0">
+            <a:pPr marL="0" indent="0">
               <a:buNone/>
             </a:pPr>
             <a:r>
@@ -6463,7 +6822,7 @@
           <a:bodyPr wrap="square" rtlCol="0" anchor="ctr"/>
           <a:lstStyle/>
           <a:p>
-            <a:pPr indent="0" marL="0">
+            <a:pPr marL="0" indent="0">
               <a:buNone/>
             </a:pPr>
             <a:r>
@@ -6505,6 +6864,13 @@
             <a:prstDash val="solid"/>
           </a:ln>
         </p:spPr>
+        <p:txBody>
+          <a:bodyPr/>
+          <a:lstStyle/>
+          <a:p>
+            <a:endParaRPr lang="en-US"/>
+          </a:p>
+        </p:txBody>
       </p:sp>
       <p:sp>
         <p:nvSpPr>
@@ -6527,7 +6893,7 @@
           <a:bodyPr wrap="square" rtlCol="0" anchor="ctr"/>
           <a:lstStyle/>
           <a:p>
-            <a:pPr indent="0" marL="0">
+            <a:pPr marL="0" indent="0">
               <a:buNone/>
             </a:pPr>
             <a:r>
@@ -6566,7 +6932,7 @@
           <a:bodyPr wrap="square" rtlCol="0" anchor="ctr"/>
           <a:lstStyle/>
           <a:p>
-            <a:pPr indent="0" marL="0">
+            <a:pPr marL="0" indent="0">
               <a:buNone/>
             </a:pPr>
             <a:r>
@@ -6605,7 +6971,7 @@
           <a:bodyPr wrap="square" rtlCol="0" anchor="ctr"/>
           <a:lstStyle/>
           <a:p>
-            <a:pPr indent="0" marL="0">
+            <a:pPr marL="0" indent="0">
               <a:buNone/>
             </a:pPr>
             <a:r>
@@ -6617,7 +6983,7 @@
                 <a:ea typeface="Calibri" pitchFamily="34" charset="-122"/>
                 <a:cs typeface="Calibri" pitchFamily="34" charset="-120"/>
               </a:rPr>
-              <a:t>Hover over every link. If the URL doesn't match the expected domain — don't click.</a:t>
+              <a:t>Hover over every link. If the URL doesn't match the expected domain . Don't click.</a:t>
             </a:r>
             <a:endParaRPr lang="en-US" sz="1000" dirty="0"/>
           </a:p>
@@ -6647,6 +7013,13 @@
             <a:prstDash val="solid"/>
           </a:ln>
         </p:spPr>
+        <p:txBody>
+          <a:bodyPr/>
+          <a:lstStyle/>
+          <a:p>
+            <a:endParaRPr lang="en-US"/>
+          </a:p>
+        </p:txBody>
       </p:sp>
       <p:sp>
         <p:nvSpPr>
@@ -6669,7 +7042,7 @@
           <a:bodyPr wrap="square" rtlCol="0" anchor="ctr"/>
           <a:lstStyle/>
           <a:p>
-            <a:pPr indent="0" marL="0">
+            <a:pPr marL="0" indent="0">
               <a:buNone/>
             </a:pPr>
             <a:r>
@@ -6708,7 +7081,7 @@
           <a:bodyPr wrap="square" rtlCol="0" anchor="ctr"/>
           <a:lstStyle/>
           <a:p>
-            <a:pPr indent="0" marL="0">
+            <a:pPr marL="0" indent="0">
               <a:buNone/>
             </a:pPr>
             <a:r>
@@ -6747,7 +7120,7 @@
           <a:bodyPr wrap="square" rtlCol="0" anchor="ctr"/>
           <a:lstStyle/>
           <a:p>
-            <a:pPr indent="0" marL="0">
+            <a:pPr marL="0" indent="0">
               <a:buNone/>
             </a:pPr>
             <a:r>
@@ -6789,6 +7162,13 @@
             <a:prstDash val="solid"/>
           </a:ln>
         </p:spPr>
+        <p:txBody>
+          <a:bodyPr/>
+          <a:lstStyle/>
+          <a:p>
+            <a:endParaRPr lang="en-US"/>
+          </a:p>
+        </p:txBody>
       </p:sp>
       <p:sp>
         <p:nvSpPr>
@@ -6811,7 +7191,7 @@
           <a:bodyPr wrap="square" rtlCol="0" anchor="ctr"/>
           <a:lstStyle/>
           <a:p>
-            <a:pPr indent="0" marL="0">
+            <a:pPr marL="0" indent="0">
               <a:buNone/>
             </a:pPr>
             <a:r>
@@ -6850,7 +7230,7 @@
           <a:bodyPr wrap="square" rtlCol="0" anchor="ctr"/>
           <a:lstStyle/>
           <a:p>
-            <a:pPr indent="0" marL="0">
+            <a:pPr marL="0" indent="0">
               <a:buNone/>
             </a:pPr>
             <a:r>
@@ -6889,7 +7269,7 @@
           <a:bodyPr wrap="square" rtlCol="0" anchor="ctr"/>
           <a:lstStyle/>
           <a:p>
-            <a:pPr indent="0" marL="0">
+            <a:pPr marL="0" indent="0">
               <a:buNone/>
             </a:pPr>
             <a:r>
@@ -6901,7 +7281,7 @@
                 <a:ea typeface="Calibri" pitchFamily="34" charset="-122"/>
                 <a:cs typeface="Calibri" pitchFamily="34" charset="-120"/>
               </a:rPr>
-              <a:t>Password managers auto-fill only on the correct domain — they won't fill on fake sites.</a:t>
+              <a:t>Password managers auto-fill only on the correct domain. They won't fill on fake sites.</a:t>
             </a:r>
             <a:endParaRPr lang="en-US" sz="1000" dirty="0"/>
           </a:p>
@@ -6931,6 +7311,13 @@
             <a:prstDash val="solid"/>
           </a:ln>
         </p:spPr>
+        <p:txBody>
+          <a:bodyPr/>
+          <a:lstStyle/>
+          <a:p>
+            <a:endParaRPr lang="en-US"/>
+          </a:p>
+        </p:txBody>
       </p:sp>
       <p:sp>
         <p:nvSpPr>
@@ -6953,7 +7340,7 @@
           <a:bodyPr wrap="square" rtlCol="0" anchor="ctr"/>
           <a:lstStyle/>
           <a:p>
-            <a:pPr indent="0" marL="0">
+            <a:pPr marL="0" indent="0">
               <a:buNone/>
             </a:pPr>
             <a:r>
@@ -6992,7 +7379,7 @@
           <a:bodyPr wrap="square" rtlCol="0" anchor="ctr"/>
           <a:lstStyle/>
           <a:p>
-            <a:pPr indent="0" marL="0">
+            <a:pPr marL="0" indent="0">
               <a:buNone/>
             </a:pPr>
             <a:r>
@@ -7031,7 +7418,7 @@
           <a:bodyPr wrap="square" rtlCol="0" anchor="ctr"/>
           <a:lstStyle/>
           <a:p>
-            <a:pPr indent="0" marL="0">
+            <a:pPr marL="0" indent="0">
               <a:buNone/>
             </a:pPr>
             <a:r>
@@ -7073,6 +7460,13 @@
             <a:prstDash val="solid"/>
           </a:ln>
         </p:spPr>
+        <p:txBody>
+          <a:bodyPr/>
+          <a:lstStyle/>
+          <a:p>
+            <a:endParaRPr lang="en-US"/>
+          </a:p>
+        </p:txBody>
       </p:sp>
       <p:sp>
         <p:nvSpPr>
@@ -7095,7 +7489,7 @@
           <a:bodyPr wrap="square" rtlCol="0" anchor="ctr"/>
           <a:lstStyle/>
           <a:p>
-            <a:pPr indent="0" marL="0">
+            <a:pPr marL="0" indent="0">
               <a:buNone/>
             </a:pPr>
             <a:r>
@@ -7134,7 +7528,7 @@
           <a:bodyPr wrap="square" rtlCol="0" anchor="ctr"/>
           <a:lstStyle/>
           <a:p>
-            <a:pPr indent="0" marL="0">
+            <a:pPr marL="0" indent="0">
               <a:buNone/>
             </a:pPr>
             <a:r>
@@ -7173,7 +7567,7 @@
           <a:bodyPr wrap="square" rtlCol="0" anchor="ctr"/>
           <a:lstStyle/>
           <a:p>
-            <a:pPr indent="0" marL="0">
+            <a:pPr marL="0" indent="0">
               <a:buNone/>
             </a:pPr>
             <a:r>
@@ -7207,6 +7601,7 @@
         <a:solidFill>
           <a:srgbClr val="0D0D0D"/>
         </a:solidFill>
+        <a:effectLst/>
       </p:bgPr>
     </p:bg>
     <p:spTree>
@@ -7247,6 +7642,13 @@
             <a:prstDash val="solid"/>
           </a:ln>
         </p:spPr>
+        <p:txBody>
+          <a:bodyPr/>
+          <a:lstStyle/>
+          <a:p>
+            <a:endParaRPr lang="en-US"/>
+          </a:p>
+        </p:txBody>
       </p:sp>
       <p:sp>
         <p:nvSpPr>
@@ -7269,11 +7671,11 @@
           <a:bodyPr wrap="square" rtlCol="0" anchor="ctr"/>
           <a:lstStyle/>
           <a:p>
-            <a:pPr indent="0" marL="0">
-              <a:buNone/>
-            </a:pPr>
-            <a:r>
-              <a:rPr lang="en-US" sz="900" spc="300" kern="0" dirty="0">
+            <a:pPr marL="0" indent="0">
+              <a:buNone/>
+            </a:pPr>
+            <a:r>
+              <a:rPr lang="en-US" sz="900" kern="0" spc="300" dirty="0">
                 <a:solidFill>
                   <a:srgbClr val="C0392B"/>
                 </a:solidFill>
@@ -7308,7 +7710,7 @@
           <a:bodyPr wrap="square" rtlCol="0" anchor="ctr"/>
           <a:lstStyle/>
           <a:p>
-            <a:pPr indent="0" marL="0">
+            <a:pPr marL="0" indent="0">
               <a:buNone/>
             </a:pPr>
             <a:r>
@@ -7347,7 +7749,7 @@
           <a:bodyPr wrap="square" rtlCol="0" anchor="ctr"/>
           <a:lstStyle/>
           <a:p>
-            <a:pPr indent="0" marL="0">
+            <a:pPr marL="0" indent="0">
               <a:buNone/>
             </a:pPr>
             <a:r>
@@ -7389,6 +7791,13 @@
             <a:prstDash val="solid"/>
           </a:ln>
         </p:spPr>
+        <p:txBody>
+          <a:bodyPr/>
+          <a:lstStyle/>
+          <a:p>
+            <a:endParaRPr lang="en-US"/>
+          </a:p>
+        </p:txBody>
       </p:sp>
       <p:sp>
         <p:nvSpPr>
@@ -7414,6 +7823,13 @@
             <a:prstDash val="solid"/>
           </a:ln>
         </p:spPr>
+        <p:txBody>
+          <a:bodyPr/>
+          <a:lstStyle/>
+          <a:p>
+            <a:endParaRPr lang="en-US"/>
+          </a:p>
+        </p:txBody>
       </p:sp>
       <p:sp>
         <p:nvSpPr>
@@ -7436,7 +7852,7 @@
           <a:bodyPr wrap="square" rtlCol="0" anchor="ctr"/>
           <a:lstStyle/>
           <a:p>
-            <a:pPr indent="0" marL="0">
+            <a:pPr marL="0" indent="0">
               <a:buNone/>
             </a:pPr>
             <a:r>
@@ -7475,7 +7891,7 @@
           <a:bodyPr wrap="square" rtlCol="0" anchor="ctr"/>
           <a:lstStyle/>
           <a:p>
-            <a:pPr indent="0" marL="0">
+            <a:pPr marL="0" indent="0">
               <a:buNone/>
             </a:pPr>
             <a:r>
@@ -7517,6 +7933,13 @@
             <a:prstDash val="solid"/>
           </a:ln>
         </p:spPr>
+        <p:txBody>
+          <a:bodyPr/>
+          <a:lstStyle/>
+          <a:p>
+            <a:endParaRPr lang="en-US"/>
+          </a:p>
+        </p:txBody>
       </p:sp>
       <p:sp>
         <p:nvSpPr>
@@ -7542,6 +7965,13 @@
             <a:prstDash val="solid"/>
           </a:ln>
         </p:spPr>
+        <p:txBody>
+          <a:bodyPr/>
+          <a:lstStyle/>
+          <a:p>
+            <a:endParaRPr lang="en-US"/>
+          </a:p>
+        </p:txBody>
       </p:sp>
       <p:sp>
         <p:nvSpPr>
@@ -7564,7 +7994,7 @@
           <a:bodyPr wrap="square" rtlCol="0" anchor="ctr"/>
           <a:lstStyle/>
           <a:p>
-            <a:pPr indent="0" marL="0">
+            <a:pPr marL="0" indent="0">
               <a:buNone/>
             </a:pPr>
             <a:r>
@@ -7603,7 +8033,7 @@
           <a:bodyPr wrap="square" rtlCol="0" anchor="ctr"/>
           <a:lstStyle/>
           <a:p>
-            <a:pPr indent="0" marL="0">
+            <a:pPr marL="0" indent="0">
               <a:buNone/>
             </a:pPr>
             <a:r>
@@ -7645,6 +8075,13 @@
             <a:prstDash val="solid"/>
           </a:ln>
         </p:spPr>
+        <p:txBody>
+          <a:bodyPr/>
+          <a:lstStyle/>
+          <a:p>
+            <a:endParaRPr lang="en-US"/>
+          </a:p>
+        </p:txBody>
       </p:sp>
       <p:sp>
         <p:nvSpPr>
@@ -7670,6 +8107,13 @@
             <a:prstDash val="solid"/>
           </a:ln>
         </p:spPr>
+        <p:txBody>
+          <a:bodyPr/>
+          <a:lstStyle/>
+          <a:p>
+            <a:endParaRPr lang="en-US"/>
+          </a:p>
+        </p:txBody>
       </p:sp>
       <p:sp>
         <p:nvSpPr>
@@ -7692,7 +8136,7 @@
           <a:bodyPr wrap="square" rtlCol="0" anchor="ctr"/>
           <a:lstStyle/>
           <a:p>
-            <a:pPr indent="0" marL="0">
+            <a:pPr marL="0" indent="0">
               <a:buNone/>
             </a:pPr>
             <a:r>
@@ -7731,7 +8175,7 @@
           <a:bodyPr wrap="square" rtlCol="0" anchor="ctr"/>
           <a:lstStyle/>
           <a:p>
-            <a:pPr indent="0" marL="0">
+            <a:pPr marL="0" indent="0">
               <a:buNone/>
             </a:pPr>
             <a:r>
@@ -7773,6 +8217,13 @@
             <a:prstDash val="solid"/>
           </a:ln>
         </p:spPr>
+        <p:txBody>
+          <a:bodyPr/>
+          <a:lstStyle/>
+          <a:p>
+            <a:endParaRPr lang="en-US"/>
+          </a:p>
+        </p:txBody>
       </p:sp>
       <p:sp>
         <p:nvSpPr>
@@ -7798,6 +8249,13 @@
             <a:prstDash val="solid"/>
           </a:ln>
         </p:spPr>
+        <p:txBody>
+          <a:bodyPr/>
+          <a:lstStyle/>
+          <a:p>
+            <a:endParaRPr lang="en-US"/>
+          </a:p>
+        </p:txBody>
       </p:sp>
       <p:sp>
         <p:nvSpPr>
@@ -7820,7 +8278,7 @@
           <a:bodyPr wrap="square" rtlCol="0" anchor="ctr"/>
           <a:lstStyle/>
           <a:p>
-            <a:pPr indent="0" marL="0">
+            <a:pPr marL="0" indent="0">
               <a:buNone/>
             </a:pPr>
             <a:r>
@@ -7859,7 +8317,7 @@
           <a:bodyPr wrap="square" rtlCol="0" anchor="ctr"/>
           <a:lstStyle/>
           <a:p>
-            <a:pPr indent="0" marL="0">
+            <a:pPr marL="0" indent="0">
               <a:buNone/>
             </a:pPr>
             <a:r>
@@ -7901,6 +8359,13 @@
             <a:prstDash val="solid"/>
           </a:ln>
         </p:spPr>
+        <p:txBody>
+          <a:bodyPr/>
+          <a:lstStyle/>
+          <a:p>
+            <a:endParaRPr lang="en-US"/>
+          </a:p>
+        </p:txBody>
       </p:sp>
       <p:sp>
         <p:nvSpPr>
@@ -7926,6 +8391,13 @@
             <a:prstDash val="solid"/>
           </a:ln>
         </p:spPr>
+        <p:txBody>
+          <a:bodyPr/>
+          <a:lstStyle/>
+          <a:p>
+            <a:endParaRPr lang="en-US"/>
+          </a:p>
+        </p:txBody>
       </p:sp>
       <p:sp>
         <p:nvSpPr>
@@ -7948,7 +8420,7 @@
           <a:bodyPr wrap="square" rtlCol="0" anchor="ctr"/>
           <a:lstStyle/>
           <a:p>
-            <a:pPr indent="0" marL="0">
+            <a:pPr marL="0" indent="0">
               <a:buNone/>
             </a:pPr>
             <a:r>
@@ -7987,7 +8459,7 @@
           <a:bodyPr wrap="square" rtlCol="0" anchor="ctr"/>
           <a:lstStyle/>
           <a:p>
-            <a:pPr indent="0" marL="0">
+            <a:pPr marL="0" indent="0">
               <a:buNone/>
             </a:pPr>
             <a:r>
@@ -8026,7 +8498,7 @@
           <a:bodyPr wrap="square" rtlCol="0" anchor="ctr"/>
           <a:lstStyle/>
           <a:p>
-            <a:pPr indent="0" marL="0">
+            <a:pPr marL="0" indent="0">
               <a:buNone/>
             </a:pPr>
             <a:r>
@@ -8060,6 +8532,7 @@
         <a:solidFill>
           <a:srgbClr val="C0392B"/>
         </a:solidFill>
+        <a:effectLst/>
       </p:bgPr>
     </p:bg>
     <p:spTree>
@@ -8097,7 +8570,7 @@
           <a:bodyPr wrap="square" rtlCol="0" anchor="ctr"/>
           <a:lstStyle/>
           <a:p>
-            <a:pPr indent="0" marL="0">
+            <a:pPr marL="0" indent="0">
               <a:buNone/>
             </a:pPr>
             <a:r>
@@ -8136,7 +8609,7 @@
           <a:bodyPr wrap="square" rtlCol="0" anchor="ctr"/>
           <a:lstStyle/>
           <a:p>
-            <a:pPr indent="0" marL="0">
+            <a:pPr marL="0" indent="0">
               <a:buNone/>
             </a:pPr>
             <a:r>
@@ -8178,6 +8651,13 @@
             <a:prstDash val="solid"/>
           </a:ln>
         </p:spPr>
+        <p:txBody>
+          <a:bodyPr/>
+          <a:lstStyle/>
+          <a:p>
+            <a:endParaRPr lang="en-US"/>
+          </a:p>
+        </p:txBody>
       </p:sp>
       <p:sp>
         <p:nvSpPr>
@@ -8200,7 +8680,7 @@
           <a:bodyPr wrap="square" rtlCol="0" anchor="ctr"/>
           <a:lstStyle/>
           <a:p>
-            <a:pPr indent="0" marL="0">
+            <a:pPr marL="0" indent="0">
               <a:buNone/>
             </a:pPr>
             <a:r>
@@ -8242,6 +8722,13 @@
             <a:prstDash val="solid"/>
           </a:ln>
         </p:spPr>
+        <p:txBody>
+          <a:bodyPr/>
+          <a:lstStyle/>
+          <a:p>
+            <a:endParaRPr lang="en-US"/>
+          </a:p>
+        </p:txBody>
       </p:sp>
       <p:sp>
         <p:nvSpPr>
@@ -8264,7 +8751,7 @@
           <a:bodyPr wrap="square" rtlCol="0" anchor="ctr"/>
           <a:lstStyle/>
           <a:p>
-            <a:pPr indent="0" marL="0">
+            <a:pPr marL="0" indent="0">
               <a:buNone/>
             </a:pPr>
             <a:r>
@@ -8306,6 +8793,13 @@
             <a:prstDash val="solid"/>
           </a:ln>
         </p:spPr>
+        <p:txBody>
+          <a:bodyPr/>
+          <a:lstStyle/>
+          <a:p>
+            <a:endParaRPr lang="en-US"/>
+          </a:p>
+        </p:txBody>
       </p:sp>
       <p:sp>
         <p:nvSpPr>
@@ -8328,7 +8822,7 @@
           <a:bodyPr wrap="square" rtlCol="0" anchor="ctr"/>
           <a:lstStyle/>
           <a:p>
-            <a:pPr indent="0" marL="0">
+            <a:pPr marL="0" indent="0">
               <a:buNone/>
             </a:pPr>
             <a:r>
@@ -8370,6 +8864,13 @@
             <a:prstDash val="solid"/>
           </a:ln>
         </p:spPr>
+        <p:txBody>
+          <a:bodyPr/>
+          <a:lstStyle/>
+          <a:p>
+            <a:endParaRPr lang="en-US"/>
+          </a:p>
+        </p:txBody>
       </p:sp>
       <p:sp>
         <p:nvSpPr>
@@ -8392,7 +8893,7 @@
           <a:bodyPr wrap="square" rtlCol="0" anchor="ctr"/>
           <a:lstStyle/>
           <a:p>
-            <a:pPr indent="0" marL="0">
+            <a:pPr marL="0" indent="0">
               <a:buNone/>
             </a:pPr>
             <a:r>
@@ -8431,13 +8932,15 @@
           <a:bodyPr wrap="square" rtlCol="0" anchor="ctr"/>
           <a:lstStyle/>
           <a:p>
-            <a:pPr indent="0" marL="0">
-              <a:buNone/>
-            </a:pPr>
-            <a:r>
-              <a:rPr lang="en-US" sz="850" dirty="0">
-                <a:solidFill>
-                  <a:srgbClr val="922B21"/>
+            <a:pPr marL="0" indent="0">
+              <a:buNone/>
+            </a:pPr>
+            <a:r>
+              <a:rPr lang="en-US" sz="1100" dirty="0">
+                <a:solidFill>
+                  <a:schemeClr val="bg2">
+                    <a:lumMod val="10000"/>
+                  </a:schemeClr>
                 </a:solidFill>
                 <a:latin typeface="Consolas" pitchFamily="34" charset="0"/>
                 <a:ea typeface="Consolas" pitchFamily="34" charset="-122"/>
@@ -8445,7 +8948,13 @@
               </a:rPr>
               <a:t>Kashaf Noor  ·  CodeAlpha Cybersecurity Internship  ·  GCUF  ·  2026</a:t>
             </a:r>
-            <a:endParaRPr lang="en-US" sz="850" dirty="0"/>
+            <a:endParaRPr lang="en-US" sz="1100" dirty="0">
+              <a:solidFill>
+                <a:schemeClr val="bg2">
+                  <a:lumMod val="10000"/>
+                </a:schemeClr>
+              </a:solidFill>
+            </a:endParaRPr>
           </a:p>
         </p:txBody>
       </p:sp>
@@ -8750,4 +9259,319 @@
     </a:ext>
   </a:extLst>
 </a:theme>
+</file>
+
+<file path=ppt/theme/theme2.xml><?xml version="1.0" encoding="utf-8"?>
+<a:theme xmlns:a="http://schemas.openxmlformats.org/drawingml/2006/main" name="Office Theme">
+  <a:themeElements>
+    <a:clrScheme name="Office">
+      <a:dk1>
+        <a:sysClr val="windowText" lastClr="000000"/>
+      </a:dk1>
+      <a:lt1>
+        <a:sysClr val="window" lastClr="FFFFFF"/>
+      </a:lt1>
+      <a:dk2>
+        <a:srgbClr val="0E2841"/>
+      </a:dk2>
+      <a:lt2>
+        <a:srgbClr val="E8E8E8"/>
+      </a:lt2>
+      <a:accent1>
+        <a:srgbClr val="156082"/>
+      </a:accent1>
+      <a:accent2>
+        <a:srgbClr val="E97132"/>
+      </a:accent2>
+      <a:accent3>
+        <a:srgbClr val="196B24"/>
+      </a:accent3>
+      <a:accent4>
+        <a:srgbClr val="0F9ED5"/>
+      </a:accent4>
+      <a:accent5>
+        <a:srgbClr val="A02B93"/>
+      </a:accent5>
+      <a:accent6>
+        <a:srgbClr val="4EA72E"/>
+      </a:accent6>
+      <a:hlink>
+        <a:srgbClr val="467886"/>
+      </a:hlink>
+      <a:folHlink>
+        <a:srgbClr val="96607D"/>
+      </a:folHlink>
+    </a:clrScheme>
+    <a:fontScheme name="Office">
+      <a:majorFont>
+        <a:latin typeface="Aptos Display" panose="02110004020202020204"/>
+        <a:ea typeface=""/>
+        <a:cs typeface=""/>
+        <a:font script="Jpan" typeface="游ゴシック Light"/>
+        <a:font script="Hang" typeface="맑은 고딕"/>
+        <a:font script="Hans" typeface="等线 Light"/>
+        <a:font script="Hant" typeface="新細明體"/>
+        <a:font script="Arab" typeface="Times New Roman"/>
+        <a:font script="Hebr" typeface="Times New Roman"/>
+        <a:font script="Thai" typeface="Angsana New"/>
+        <a:font script="Ethi" typeface="Nyala"/>
+        <a:font script="Beng" typeface="Vrinda"/>
+        <a:font script="Gujr" typeface="Shruti"/>
+        <a:font script="Khmr" typeface="MoolBoran"/>
+        <a:font script="Knda" typeface="Tunga"/>
+        <a:font script="Guru" typeface="Raavi"/>
+        <a:font script="Cans" typeface="Euphemia"/>
+        <a:font script="Cher" typeface="Plantagenet Cherokee"/>
+        <a:font script="Yiii" typeface="Microsoft Yi Baiti"/>
+        <a:font script="Tibt" typeface="Microsoft Himalaya"/>
+        <a:font script="Thaa" typeface="MV Boli"/>
+        <a:font script="Deva" typeface="Mangal"/>
+        <a:font script="Telu" typeface="Gautami"/>
+        <a:font script="Taml" typeface="Latha"/>
+        <a:font script="Syrc" typeface="Estrangelo Edessa"/>
+        <a:font script="Orya" typeface="Kalinga"/>
+        <a:font script="Mlym" typeface="Kartika"/>
+        <a:font script="Laoo" typeface="DokChampa"/>
+        <a:font script="Sinh" typeface="Iskoola Pota"/>
+        <a:font script="Mong" typeface="Mongolian Baiti"/>
+        <a:font script="Viet" typeface="Times New Roman"/>
+        <a:font script="Uigh" typeface="Microsoft Uighur"/>
+        <a:font script="Geor" typeface="Sylfaen"/>
+        <a:font script="Armn" typeface="Arial"/>
+        <a:font script="Bugi" typeface="Leelawadee UI"/>
+        <a:font script="Bopo" typeface="Microsoft JhengHei"/>
+        <a:font script="Java" typeface="Javanese Text"/>
+        <a:font script="Lisu" typeface="Segoe UI"/>
+        <a:font script="Mymr" typeface="Myanmar Text"/>
+        <a:font script="Nkoo" typeface="Ebrima"/>
+        <a:font script="Olck" typeface="Nirmala UI"/>
+        <a:font script="Osma" typeface="Ebrima"/>
+        <a:font script="Phag" typeface="Phagspa"/>
+        <a:font script="Syrn" typeface="Estrangelo Edessa"/>
+        <a:font script="Syrj" typeface="Estrangelo Edessa"/>
+        <a:font script="Syre" typeface="Estrangelo Edessa"/>
+        <a:font script="Sora" typeface="Nirmala UI"/>
+        <a:font script="Tale" typeface="Microsoft Tai Le"/>
+        <a:font script="Talu" typeface="Microsoft New Tai Lue"/>
+        <a:font script="Tfng" typeface="Ebrima"/>
+      </a:majorFont>
+      <a:minorFont>
+        <a:latin typeface="Aptos" panose="02110004020202020204"/>
+        <a:ea typeface=""/>
+        <a:cs typeface=""/>
+        <a:font script="Jpan" typeface="游ゴシック"/>
+        <a:font script="Hang" typeface="맑은 고딕"/>
+        <a:font script="Hans" typeface="等线"/>
+        <a:font script="Hant" typeface="新細明體"/>
+        <a:font script="Arab" typeface="Arial"/>
+        <a:font script="Hebr" typeface="Arial"/>
+        <a:font script="Thai" typeface="Cordia New"/>
+        <a:font script="Ethi" typeface="Nyala"/>
+        <a:font script="Beng" typeface="Vrinda"/>
+        <a:font script="Gujr" typeface="Shruti"/>
+        <a:font script="Khmr" typeface="DaunPenh"/>
+        <a:font script="Knda" typeface="Tunga"/>
+        <a:font script="Guru" typeface="Raavi"/>
+        <a:font script="Cans" typeface="Euphemia"/>
+        <a:font script="Cher" typeface="Plantagenet Cherokee"/>
+        <a:font script="Yiii" typeface="Microsoft Yi Baiti"/>
+        <a:font script="Tibt" typeface="Microsoft Himalaya"/>
+        <a:font script="Thaa" typeface="MV Boli"/>
+        <a:font script="Deva" typeface="Mangal"/>
+        <a:font script="Telu" typeface="Gautami"/>
+        <a:font script="Taml" typeface="Latha"/>
+        <a:font script="Syrc" typeface="Estrangelo Edessa"/>
+        <a:font script="Orya" typeface="Kalinga"/>
+        <a:font script="Mlym" typeface="Kartika"/>
+        <a:font script="Laoo" typeface="DokChampa"/>
+        <a:font script="Sinh" typeface="Iskoola Pota"/>
+        <a:font script="Mong" typeface="Mongolian Baiti"/>
+        <a:font script="Viet" typeface="Arial"/>
+        <a:font script="Uigh" typeface="Microsoft Uighur"/>
+        <a:font script="Geor" typeface="Sylfaen"/>
+        <a:font script="Armn" typeface="Arial"/>
+        <a:font script="Bugi" typeface="Leelawadee UI"/>
+        <a:font script="Bopo" typeface="Microsoft JhengHei"/>
+        <a:font script="Java" typeface="Javanese Text"/>
+        <a:font script="Lisu" typeface="Segoe UI"/>
+        <a:font script="Mymr" typeface="Myanmar Text"/>
+        <a:font script="Nkoo" typeface="Ebrima"/>
+        <a:font script="Olck" typeface="Nirmala UI"/>
+        <a:font script="Osma" typeface="Ebrima"/>
+        <a:font script="Phag" typeface="Phagspa"/>
+        <a:font script="Syrn" typeface="Estrangelo Edessa"/>
+        <a:font script="Syrj" typeface="Estrangelo Edessa"/>
+        <a:font script="Syre" typeface="Estrangelo Edessa"/>
+        <a:font script="Sora" typeface="Nirmala UI"/>
+        <a:font script="Tale" typeface="Microsoft Tai Le"/>
+        <a:font script="Talu" typeface="Microsoft New Tai Lue"/>
+        <a:font script="Tfng" typeface="Ebrima"/>
+      </a:minorFont>
+    </a:fontScheme>
+    <a:fmtScheme name="Office">
+      <a:fillStyleLst>
+        <a:solidFill>
+          <a:schemeClr val="phClr"/>
+        </a:solidFill>
+        <a:gradFill rotWithShape="1">
+          <a:gsLst>
+            <a:gs pos="0">
+              <a:schemeClr val="phClr">
+                <a:lumMod val="110000"/>
+                <a:satMod val="105000"/>
+                <a:tint val="67000"/>
+              </a:schemeClr>
+            </a:gs>
+            <a:gs pos="50000">
+              <a:schemeClr val="phClr">
+                <a:lumMod val="105000"/>
+                <a:satMod val="103000"/>
+                <a:tint val="73000"/>
+              </a:schemeClr>
+            </a:gs>
+            <a:gs pos="100000">
+              <a:schemeClr val="phClr">
+                <a:lumMod val="105000"/>
+                <a:satMod val="109000"/>
+                <a:tint val="81000"/>
+              </a:schemeClr>
+            </a:gs>
+          </a:gsLst>
+          <a:lin ang="5400000" scaled="0"/>
+        </a:gradFill>
+        <a:gradFill rotWithShape="1">
+          <a:gsLst>
+            <a:gs pos="0">
+              <a:schemeClr val="phClr">
+                <a:satMod val="103000"/>
+                <a:lumMod val="102000"/>
+                <a:tint val="94000"/>
+              </a:schemeClr>
+            </a:gs>
+            <a:gs pos="50000">
+              <a:schemeClr val="phClr">
+                <a:satMod val="110000"/>
+                <a:lumMod val="100000"/>
+                <a:shade val="100000"/>
+              </a:schemeClr>
+            </a:gs>
+            <a:gs pos="100000">
+              <a:schemeClr val="phClr">
+                <a:lumMod val="99000"/>
+                <a:satMod val="120000"/>
+                <a:shade val="78000"/>
+              </a:schemeClr>
+            </a:gs>
+          </a:gsLst>
+          <a:lin ang="5400000" scaled="0"/>
+        </a:gradFill>
+      </a:fillStyleLst>
+      <a:lnStyleLst>
+        <a:ln w="12700" cap="flat" cmpd="sng" algn="ctr">
+          <a:solidFill>
+            <a:schemeClr val="phClr"/>
+          </a:solidFill>
+          <a:prstDash val="solid"/>
+          <a:miter lim="800000"/>
+        </a:ln>
+        <a:ln w="19050" cap="flat" cmpd="sng" algn="ctr">
+          <a:solidFill>
+            <a:schemeClr val="phClr"/>
+          </a:solidFill>
+          <a:prstDash val="solid"/>
+          <a:miter lim="800000"/>
+        </a:ln>
+        <a:ln w="25400" cap="flat" cmpd="sng" algn="ctr">
+          <a:solidFill>
+            <a:schemeClr val="phClr"/>
+          </a:solidFill>
+          <a:prstDash val="solid"/>
+          <a:miter lim="800000"/>
+        </a:ln>
+      </a:lnStyleLst>
+      <a:effectStyleLst>
+        <a:effectStyle>
+          <a:effectLst/>
+        </a:effectStyle>
+        <a:effectStyle>
+          <a:effectLst/>
+        </a:effectStyle>
+        <a:effectStyle>
+          <a:effectLst>
+            <a:outerShdw blurRad="57150" dist="19050" dir="5400000" algn="ctr" rotWithShape="0">
+              <a:srgbClr val="000000">
+                <a:alpha val="63000"/>
+              </a:srgbClr>
+            </a:outerShdw>
+          </a:effectLst>
+        </a:effectStyle>
+      </a:effectStyleLst>
+      <a:bgFillStyleLst>
+        <a:solidFill>
+          <a:schemeClr val="phClr"/>
+        </a:solidFill>
+        <a:solidFill>
+          <a:schemeClr val="phClr">
+            <a:tint val="95000"/>
+            <a:satMod val="170000"/>
+          </a:schemeClr>
+        </a:solidFill>
+        <a:gradFill rotWithShape="1">
+          <a:gsLst>
+            <a:gs pos="0">
+              <a:schemeClr val="phClr">
+                <a:tint val="93000"/>
+                <a:satMod val="150000"/>
+                <a:shade val="98000"/>
+                <a:lumMod val="102000"/>
+              </a:schemeClr>
+            </a:gs>
+            <a:gs pos="50000">
+              <a:schemeClr val="phClr">
+                <a:tint val="98000"/>
+                <a:satMod val="130000"/>
+                <a:shade val="90000"/>
+                <a:lumMod val="103000"/>
+              </a:schemeClr>
+            </a:gs>
+            <a:gs pos="100000">
+              <a:schemeClr val="phClr">
+                <a:shade val="63000"/>
+                <a:satMod val="120000"/>
+              </a:schemeClr>
+            </a:gs>
+          </a:gsLst>
+          <a:lin ang="5400000" scaled="0"/>
+        </a:gradFill>
+      </a:bgFillStyleLst>
+    </a:fmtScheme>
+  </a:themeElements>
+  <a:objectDefaults>
+    <a:lnDef>
+      <a:spPr/>
+      <a:bodyPr/>
+      <a:lstStyle/>
+      <a:style>
+        <a:lnRef idx="2">
+          <a:schemeClr val="accent1"/>
+        </a:lnRef>
+        <a:fillRef idx="0">
+          <a:schemeClr val="accent1"/>
+        </a:fillRef>
+        <a:effectRef idx="1">
+          <a:schemeClr val="accent1"/>
+        </a:effectRef>
+        <a:fontRef idx="minor">
+          <a:schemeClr val="tx1"/>
+        </a:fontRef>
+      </a:style>
+    </a:lnDef>
+  </a:objectDefaults>
+  <a:extraClrSchemeLst/>
+  <a:extLst>
+    <a:ext uri="{05A4C25C-085E-4340-85A3-A5531E510DB2}">
+      <thm15:themeFamily xmlns:thm15="http://schemas.microsoft.com/office/thememl/2012/main" name="Office Theme" id="{2E142A2C-CD16-42D6-873A-C26D2A0506FA}" vid="{1BDDFF52-6CD6-40A5-AB3C-68EB2F1E4D0A}"/>
+    </a:ext>
+  </a:extLst>
+</a:theme>
 </file>
</xml_diff>